<commit_message>
Slides: sixteen one-idea slides in plain language
Co-Authored-By: Claude Fable 5.1 <noreply@anthropic.com>
Claude-Session: https://claude.ai/code/session_018qJiaQKKjpemqx8e3Wrmcq
</commit_message>
<xml_diff>
--- a/report/slides.pptx
+++ b/report/slides.pptx
@@ -13,6 +13,14 @@
     <p:sldId id="261" r:id="rId12"/>
     <p:sldId id="262" r:id="rId13"/>
     <p:sldId id="263" r:id="rId14"/>
+    <p:sldId id="264" r:id="rId15"/>
+    <p:sldId id="265" r:id="rId16"/>
+    <p:sldId id="266" r:id="rId17"/>
+    <p:sldId id="267" r:id="rId18"/>
+    <p:sldId id="268" r:id="rId19"/>
+    <p:sldId id="269" r:id="rId20"/>
+    <p:sldId id="270" r:id="rId21"/>
+    <p:sldId id="271" r:id="rId22"/>
   </p:sldIdLst>
   <p:sldSz cx="12191695" cy="6858000" type="screen4x3"/>
   <p:notesSz cx="6858000" cy="9144000"/>
@@ -3103,8 +3111,8 @@
         </p:nvSpPr>
         <p:spPr>
           <a:xfrm>
-            <a:off x="731520" y="2011680"/>
-            <a:ext cx="10698480" cy="1463040"/>
+            <a:off x="731520" y="2103120"/>
+            <a:ext cx="10698480" cy="1280160"/>
           </a:xfrm>
           <a:prstGeom prst="rect">
             <a:avLst/>
@@ -3117,7 +3125,11 @@
           </a:bodyPr>
           <a:lstStyle/>
           <a:p>
-            <a:pPr algn="l"/>
+            <a:pPr>
+              <a:spcAft>
+                <a:spcPts val="1000"/>
+              </a:spcAft>
+            </a:pPr>
             <a:r>
               <a:rPr sz="4400" b="1">
                 <a:solidFill>
@@ -3139,7 +3151,7 @@
         <p:spPr>
           <a:xfrm>
             <a:off x="731520" y="3200400"/>
-            <a:ext cx="10698480" cy="914400"/>
+            <a:ext cx="10698480" cy="822960"/>
           </a:xfrm>
           <a:prstGeom prst="rect">
             <a:avLst/>
@@ -3152,15 +3164,19 @@
           </a:bodyPr>
           <a:lstStyle/>
           <a:p>
-            <a:pPr algn="l"/>
+            <a:pPr>
+              <a:spcAft>
+                <a:spcPts val="1000"/>
+              </a:spcAft>
+            </a:pPr>
             <a:r>
               <a:rPr sz="2600" b="0">
                 <a:solidFill>
-                  <a:srgbClr val="555555"/>
-                </a:solidFill>
-                <a:latin typeface="Calibri"/>
-              </a:rPr>
-              <a:t>Calibration, Innocent Dependence, and Coalition Size</a:t>
+                  <a:srgbClr val="444444"/>
+                </a:solidFill>
+                <a:latin typeface="Calibri"/>
+              </a:rPr>
+              <a:t>Calibration, innocent dependence, and coalition size</a:t>
             </a:r>
           </a:p>
         </p:txBody>
@@ -3173,7 +3189,7 @@
         </p:nvSpPr>
         <p:spPr>
           <a:xfrm>
-            <a:off x="731520" y="4389120"/>
+            <a:off x="731520" y="4480560"/>
             <a:ext cx="10698480" cy="1097280"/>
           </a:xfrm>
           <a:prstGeom prst="rect">
@@ -3187,11 +3203,15 @@
           </a:bodyPr>
           <a:lstStyle/>
           <a:p>
-            <a:pPr algn="l"/>
+            <a:pPr>
+              <a:spcAft>
+                <a:spcPts val="1000"/>
+              </a:spcAft>
+            </a:pPr>
             <a:r>
               <a:rPr sz="1600" b="0">
                 <a:solidFill>
-                  <a:srgbClr val="555555"/>
+                  <a:srgbClr val="444444"/>
                 </a:solidFill>
                 <a:latin typeface="Calibri"/>
               </a:rPr>
@@ -3199,23 +3219,1366 @@
             </a:r>
           </a:p>
           <a:p>
-            <a:pPr algn="l"/>
+            <a:pPr>
+              <a:spcAft>
+                <a:spcPts val="1000"/>
+              </a:spcAft>
+            </a:pPr>
             <a:r>
               <a:rPr sz="1600" b="0">
                 <a:solidFill>
-                  <a:srgbClr val="555555"/>
-                </a:solidFill>
-                <a:latin typeface="Calibri"/>
-              </a:rPr>
-              <a:t>Apart Research AI Collusion Sprint, October 2026. Tracks 1 and 2.</a:t>
-            </a:r>
-          </a:p>
-          <a:p>
-            <a:pPr algn="l"/>
+                  <a:srgbClr val="444444"/>
+                </a:solidFill>
+                <a:latin typeface="Calibri"/>
+              </a:rPr>
+              <a:t>Apart Research AI Collusion Sprint, October 2026</a:t>
+            </a:r>
+          </a:p>
+          <a:p>
+            <a:pPr>
+              <a:spcAft>
+                <a:spcPts val="1000"/>
+              </a:spcAft>
+            </a:pPr>
             <a:r>
               <a:rPr sz="1600" b="0">
                 <a:solidFill>
-                  <a:srgbClr val="555555"/>
+                  <a:srgbClr val="444444"/>
+                </a:solidFill>
+                <a:latin typeface="Calibri"/>
+              </a:rPr>
+              <a:t>github.com/in-a-quantum-world/collusion-net-influence</a:t>
+            </a:r>
+          </a:p>
+        </p:txBody>
+      </p:sp>
+    </p:spTree>
+  </p:cSld>
+  <p:clrMapOvr>
+    <a:masterClrMapping/>
+  </p:clrMapOvr>
+</p:sld>
+</file>
+
+<file path=ppt/slides/slide10.xml><?xml version="1.0" encoding="utf-8"?>
+<p:sld xmlns:a="http://schemas.openxmlformats.org/drawingml/2006/main" xmlns:p="http://schemas.openxmlformats.org/presentationml/2006/main" xmlns:r="http://schemas.openxmlformats.org/officeDocument/2006/relationships">
+  <p:cSld>
+    <p:spTree>
+      <p:nvGrpSpPr>
+        <p:cNvPr id="1" name=""/>
+        <p:cNvGrpSpPr/>
+        <p:nvPr/>
+      </p:nvGrpSpPr>
+      <p:grpSpPr/>
+      <p:sp>
+        <p:nvSpPr>
+          <p:cNvPr id="2" name="TextBox 1"/>
+          <p:cNvSpPr txBox="1"/>
+          <p:nvPr/>
+        </p:nvSpPr>
+        <p:spPr>
+          <a:xfrm>
+            <a:off x="548640" y="365760"/>
+            <a:ext cx="11064240" cy="1005840"/>
+          </a:xfrm>
+          <a:prstGeom prst="rect">
+            <a:avLst/>
+          </a:prstGeom>
+          <a:noFill/>
+        </p:spPr>
+        <p:txBody>
+          <a:bodyPr wrap="square">
+            <a:spAutoFit/>
+          </a:bodyPr>
+          <a:lstStyle/>
+          <a:p>
+            <a:pPr>
+              <a:spcAft>
+                <a:spcPts val="1000"/>
+              </a:spcAft>
+            </a:pPr>
+            <a:r>
+              <a:rPr sz="3000" b="1">
+                <a:solidFill>
+                  <a:srgbClr val="1F3A5F"/>
+                </a:solidFill>
+                <a:latin typeface="Calibri"/>
+              </a:rPr>
+              <a:t>Finding 3: the correction cancels a coalition of three</a:t>
+            </a:r>
+          </a:p>
+        </p:txBody>
+      </p:sp>
+      <p:sp>
+        <p:nvSpPr>
+          <p:cNvPr id="3" name="TextBox 2"/>
+          <p:cNvSpPr txBox="1"/>
+          <p:nvPr/>
+        </p:nvSpPr>
+        <p:spPr>
+          <a:xfrm>
+            <a:off x="548640" y="1645920"/>
+            <a:ext cx="11064240" cy="4754880"/>
+          </a:xfrm>
+          <a:prstGeom prst="rect">
+            <a:avLst/>
+          </a:prstGeom>
+          <a:noFill/>
+        </p:spPr>
+        <p:txBody>
+          <a:bodyPr wrap="square">
+            <a:spAutoFit/>
+          </a:bodyPr>
+          <a:lstStyle/>
+          <a:p>
+            <a:pPr>
+              <a:spcAft>
+                <a:spcPts val="1000"/>
+              </a:spcAft>
+            </a:pPr>
+            <a:r>
+              <a:rPr sz="2200" b="0">
+                <a:solidFill>
+                  <a:srgbClr val="444444"/>
+                </a:solidFill>
+                <a:latin typeface="Calibri"/>
+              </a:rPr>
+              <a:t>A primary agent A, two assistants B and C.</a:t>
+            </a:r>
+          </a:p>
+          <a:p>
+            <a:pPr>
+              <a:spcAft>
+                <a:spcPts val="1000"/>
+              </a:spcAft>
+            </a:pPr>
+            <a:r>
+              <a:rPr sz="2200" b="0">
+                <a:solidFill>
+                  <a:srgbClr val="444444"/>
+                </a:solidFill>
+                <a:latin typeface="Calibri"/>
+              </a:rPr>
+              <a:t/>
+            </a:r>
+          </a:p>
+          <a:p>
+            <a:pPr>
+              <a:spcAft>
+                <a:spcPts val="1000"/>
+              </a:spcAft>
+            </a:pPr>
+            <a:r>
+              <a:rPr sz="2200" b="0">
+                <a:solidFill>
+                  <a:srgbClr val="444444"/>
+                </a:solidFill>
+                <a:latin typeface="Calibri"/>
+              </a:rPr>
+              <a:t>B's influence on A and C's influence on A are equal in expectation.</a:t>
+            </a:r>
+          </a:p>
+          <a:p>
+            <a:pPr>
+              <a:spcAft>
+                <a:spcPts val="1000"/>
+              </a:spcAft>
+            </a:pPr>
+            <a:r>
+              <a:rPr sz="2200" b="0">
+                <a:solidFill>
+                  <a:srgbClr val="444444"/>
+                </a:solidFill>
+                <a:latin typeface="Calibri"/>
+              </a:rPr>
+              <a:t/>
+            </a:r>
+          </a:p>
+          <a:p>
+            <a:pPr>
+              <a:spcAft>
+                <a:spcPts val="1000"/>
+              </a:spcAft>
+            </a:pPr>
+            <a:r>
+              <a:rPr sz="2200" b="0">
+                <a:solidFill>
+                  <a:srgbClr val="444444"/>
+                </a:solidFill>
+                <a:latin typeface="Calibri"/>
+              </a:rPr>
+              <a:t>Net influence subtracts the larger of the others' influence, so B's net score on A is m minus m, which is zero.</a:t>
+            </a:r>
+          </a:p>
+          <a:p>
+            <a:pPr>
+              <a:spcAft>
+                <a:spcPts val="1000"/>
+              </a:spcAft>
+            </a:pPr>
+            <a:r>
+              <a:rPr sz="2200" b="0">
+                <a:solidFill>
+                  <a:srgbClr val="444444"/>
+                </a:solidFill>
+                <a:latin typeface="Calibri"/>
+              </a:rPr>
+              <a:t/>
+            </a:r>
+          </a:p>
+          <a:p>
+            <a:pPr>
+              <a:spcAft>
+                <a:spcPts val="1000"/>
+              </a:spcAft>
+            </a:pPr>
+            <a:r>
+              <a:rPr sz="2200" b="0">
+                <a:solidFill>
+                  <a:srgbClr val="444444"/>
+                </a:solidFill>
+                <a:latin typeface="Calibri"/>
+              </a:rPr>
+              <a:t>The method removes the coalition's own signal.</a:t>
+            </a:r>
+          </a:p>
+        </p:txBody>
+      </p:sp>
+    </p:spTree>
+  </p:cSld>
+  <p:clrMapOvr>
+    <a:masterClrMapping/>
+  </p:clrMapOvr>
+</p:sld>
+</file>
+
+<file path=ppt/slides/slide11.xml><?xml version="1.0" encoding="utf-8"?>
+<p:sld xmlns:a="http://schemas.openxmlformats.org/drawingml/2006/main" xmlns:p="http://schemas.openxmlformats.org/presentationml/2006/main" xmlns:r="http://schemas.openxmlformats.org/officeDocument/2006/relationships">
+  <p:cSld>
+    <p:spTree>
+      <p:nvGrpSpPr>
+        <p:cNvPr id="1" name=""/>
+        <p:cNvGrpSpPr/>
+        <p:nvPr/>
+      </p:nvGrpSpPr>
+      <p:grpSpPr/>
+      <p:sp>
+        <p:nvSpPr>
+          <p:cNvPr id="2" name="TextBox 1"/>
+          <p:cNvSpPr txBox="1"/>
+          <p:nvPr/>
+        </p:nvSpPr>
+        <p:spPr>
+          <a:xfrm>
+            <a:off x="548640" y="365760"/>
+            <a:ext cx="11064240" cy="1005840"/>
+          </a:xfrm>
+          <a:prstGeom prst="rect">
+            <a:avLst/>
+          </a:prstGeom>
+          <a:noFill/>
+        </p:spPr>
+        <p:txBody>
+          <a:bodyPr wrap="square">
+            <a:spAutoFit/>
+          </a:bodyPr>
+          <a:lstStyle/>
+          <a:p>
+            <a:pPr>
+              <a:spcAft>
+                <a:spcPts val="1000"/>
+              </a:spcAft>
+            </a:pPr>
+            <a:r>
+              <a:rPr sz="3000" b="1">
+                <a:solidFill>
+                  <a:srgbClr val="1F3A5F"/>
+                </a:solidFill>
+                <a:latin typeface="Calibri"/>
+              </a:rPr>
+              <a:t>More data, less detection</a:t>
+            </a:r>
+          </a:p>
+        </p:txBody>
+      </p:sp>
+      <p:pic>
+        <p:nvPicPr>
+          <p:cNvPr id="3" name="Picture 2" descr="fig_extensions.png"/>
+          <p:cNvPicPr>
+            <a:picLocks noChangeAspect="1"/>
+          </p:cNvPicPr>
+          <p:nvPr/>
+        </p:nvPicPr>
+        <p:blipFill>
+          <a:blip r:embed="rId2"/>
+          <a:stretch>
+            <a:fillRect/>
+          </a:stretch>
+        </p:blipFill>
+        <p:spPr>
+          <a:xfrm>
+            <a:off x="548640" y="1554480"/>
+            <a:ext cx="6766560" cy="2008140"/>
+          </a:xfrm>
+          <a:prstGeom prst="rect">
+            <a:avLst/>
+          </a:prstGeom>
+        </p:spPr>
+      </p:pic>
+      <p:sp>
+        <p:nvSpPr>
+          <p:cNvPr id="4" name="TextBox 3"/>
+          <p:cNvSpPr txBox="1"/>
+          <p:nvPr/>
+        </p:nvSpPr>
+        <p:spPr>
+          <a:xfrm>
+            <a:off x="7680960" y="1645920"/>
+            <a:ext cx="3931919" cy="4754880"/>
+          </a:xfrm>
+          <a:prstGeom prst="rect">
+            <a:avLst/>
+          </a:prstGeom>
+          <a:noFill/>
+        </p:spPr>
+        <p:txBody>
+          <a:bodyPr wrap="square">
+            <a:spAutoFit/>
+          </a:bodyPr>
+          <a:lstStyle/>
+          <a:p>
+            <a:pPr>
+              <a:spcAft>
+                <a:spcPts val="1000"/>
+              </a:spcAft>
+            </a:pPr>
+            <a:r>
+              <a:rPr sz="1900" b="0">
+                <a:solidFill>
+                  <a:srgbClr val="444444"/>
+                </a:solidFill>
+                <a:latin typeface="Calibri"/>
+              </a:rPr>
+              <a:t>The true pair's score falls to 0.006 nats at 500 rounds.</a:t>
+            </a:r>
+          </a:p>
+          <a:p>
+            <a:pPr>
+              <a:spcAft>
+                <a:spcPts val="1000"/>
+              </a:spcAft>
+            </a:pPr>
+            <a:r>
+              <a:rPr sz="1900" b="0">
+                <a:solidFill>
+                  <a:srgbClr val="444444"/>
+                </a:solidFill>
+                <a:latin typeface="Calibri"/>
+              </a:rPr>
+              <a:t/>
+            </a:r>
+          </a:p>
+          <a:p>
+            <a:pPr>
+              <a:spcAft>
+                <a:spcPts val="1000"/>
+              </a:spcAft>
+            </a:pPr>
+            <a:r>
+              <a:rPr sz="1900" b="0">
+                <a:solidFill>
+                  <a:srgbClr val="444444"/>
+                </a:solidFill>
+                <a:latin typeface="Calibri"/>
+              </a:rPr>
+              <a:t>The fixed rule returns no pair in 25%, 32%, 54% and 68% of games at 50, 100, 200 and 500 rounds.</a:t>
+            </a:r>
+          </a:p>
+          <a:p>
+            <a:pPr>
+              <a:spcAft>
+                <a:spcPts val="1000"/>
+              </a:spcAft>
+            </a:pPr>
+            <a:r>
+              <a:rPr sz="1900" b="0">
+                <a:solidFill>
+                  <a:srgbClr val="444444"/>
+                </a:solidFill>
+                <a:latin typeface="Calibri"/>
+              </a:rPr>
+              <a:t/>
+            </a:r>
+          </a:p>
+          <a:p>
+            <a:pPr>
+              <a:spcAft>
+                <a:spcPts val="1000"/>
+              </a:spcAft>
+            </a:pPr>
+            <a:r>
+              <a:rPr sz="1900" b="0">
+                <a:solidFill>
+                  <a:srgbClr val="444444"/>
+                </a:solidFill>
+                <a:latin typeface="Calibri"/>
+              </a:rPr>
+              <a:t>Ranking still works. Thresholding does not.</a:t>
+            </a:r>
+          </a:p>
+        </p:txBody>
+      </p:sp>
+    </p:spTree>
+  </p:cSld>
+  <p:clrMapOvr>
+    <a:masterClrMapping/>
+  </p:clrMapOvr>
+</p:sld>
+</file>
+
+<file path=ppt/slides/slide12.xml><?xml version="1.0" encoding="utf-8"?>
+<p:sld xmlns:a="http://schemas.openxmlformats.org/drawingml/2006/main" xmlns:p="http://schemas.openxmlformats.org/presentationml/2006/main" xmlns:r="http://schemas.openxmlformats.org/officeDocument/2006/relationships">
+  <p:cSld>
+    <p:spTree>
+      <p:nvGrpSpPr>
+        <p:cNvPr id="1" name=""/>
+        <p:cNvGrpSpPr/>
+        <p:nvPr/>
+      </p:nvGrpSpPr>
+      <p:grpSpPr/>
+      <p:sp>
+        <p:nvSpPr>
+          <p:cNvPr id="2" name="TextBox 1"/>
+          <p:cNvSpPr txBox="1"/>
+          <p:nvPr/>
+        </p:nvSpPr>
+        <p:spPr>
+          <a:xfrm>
+            <a:off x="548640" y="365760"/>
+            <a:ext cx="11064240" cy="1005840"/>
+          </a:xfrm>
+          <a:prstGeom prst="rect">
+            <a:avLst/>
+          </a:prstGeom>
+          <a:noFill/>
+        </p:spPr>
+        <p:txBody>
+          <a:bodyPr wrap="square">
+            <a:spAutoFit/>
+          </a:bodyPr>
+          <a:lstStyle/>
+          <a:p>
+            <a:pPr>
+              <a:spcAft>
+                <a:spcPts val="1000"/>
+              </a:spcAft>
+            </a:pPr>
+            <a:r>
+              <a:rPr sz="3000" b="1">
+                <a:solidFill>
+                  <a:srgbClr val="1F3A5F"/>
+                </a:solidFill>
+                <a:latin typeface="Calibri"/>
+              </a:rPr>
+              <a:t>Finding 4: on real agents, three different numbers</a:t>
+            </a:r>
+          </a:p>
+        </p:txBody>
+      </p:sp>
+      <p:sp>
+        <p:nvSpPr>
+          <p:cNvPr id="3" name="TextBox 2"/>
+          <p:cNvSpPr txBox="1"/>
+          <p:nvPr/>
+        </p:nvSpPr>
+        <p:spPr>
+          <a:xfrm>
+            <a:off x="548640" y="1645920"/>
+            <a:ext cx="11064240" cy="4754880"/>
+          </a:xfrm>
+          <a:prstGeom prst="rect">
+            <a:avLst/>
+          </a:prstGeom>
+          <a:noFill/>
+        </p:spPr>
+        <p:txBody>
+          <a:bodyPr wrap="square">
+            <a:spAutoFit/>
+          </a:bodyPr>
+          <a:lstStyle/>
+          <a:p>
+            <a:pPr>
+              <a:spcAft>
+                <a:spcPts val="1000"/>
+              </a:spcAft>
+            </a:pPr>
+            <a:r>
+              <a:rPr sz="2200" b="0">
+                <a:solidFill>
+                  <a:srgbClr val="444444"/>
+                </a:solidFill>
+                <a:latin typeface="Calibri"/>
+              </a:rPr>
+              <a:t>GPT-4.1-mini, four players, 25 rounds, private channel for two of them.</a:t>
+            </a:r>
+          </a:p>
+          <a:p>
+            <a:pPr>
+              <a:spcAft>
+                <a:spcPts val="1000"/>
+              </a:spcAft>
+            </a:pPr>
+            <a:r>
+              <a:rPr sz="2200" b="0">
+                <a:solidFill>
+                  <a:srgbClr val="444444"/>
+                </a:solidFill>
+                <a:latin typeface="Calibri"/>
+              </a:rPr>
+              <a:t/>
+            </a:r>
+          </a:p>
+          <a:p>
+            <a:pPr>
+              <a:spcAft>
+                <a:spcPts val="1000"/>
+              </a:spcAft>
+            </a:pPr>
+            <a:r>
+              <a:rPr sz="2200" b="0">
+                <a:solidFill>
+                  <a:srgbClr val="444444"/>
+                </a:solidFill>
+                <a:latin typeface="Calibri"/>
+              </a:rPr>
+              <a:t>The pair is ranked first in 8 or 9 of 10 single games.</a:t>
+            </a:r>
+          </a:p>
+          <a:p>
+            <a:pPr>
+              <a:spcAft>
+                <a:spcPts val="1000"/>
+              </a:spcAft>
+            </a:pPr>
+            <a:r>
+              <a:rPr sz="2200" b="0">
+                <a:solidFill>
+                  <a:srgbClr val="444444"/>
+                </a:solidFill>
+                <a:latin typeface="Calibri"/>
+              </a:rPr>
+              <a:t/>
+            </a:r>
+          </a:p>
+          <a:p>
+            <a:pPr>
+              <a:spcAft>
+                <a:spcPts val="1000"/>
+              </a:spcAft>
+            </a:pPr>
+            <a:r>
+              <a:rPr sz="2200" b="0">
+                <a:solidFill>
+                  <a:srgbClr val="444444"/>
+                </a:solidFill>
+                <a:latin typeface="Calibri"/>
+              </a:rPr>
+              <a:t>The fixed rule flags it in 5 or 7 of 10.</a:t>
+            </a:r>
+          </a:p>
+          <a:p>
+            <a:pPr>
+              <a:spcAft>
+                <a:spcPts val="1000"/>
+              </a:spcAft>
+            </a:pPr>
+            <a:r>
+              <a:rPr sz="2200" b="0">
+                <a:solidFill>
+                  <a:srgbClr val="444444"/>
+                </a:solidFill>
+                <a:latin typeface="Calibri"/>
+              </a:rPr>
+              <a:t/>
+            </a:r>
+          </a:p>
+          <a:p>
+            <a:pPr>
+              <a:spcAft>
+                <a:spcPts val="1000"/>
+              </a:spcAft>
+            </a:pPr>
+            <a:r>
+              <a:rPr sz="2200" b="0">
+                <a:solidFill>
+                  <a:srgbClr val="444444"/>
+                </a:solidFill>
+                <a:latin typeface="Calibri"/>
+              </a:rPr>
+              <a:t>Its score advantage was -0.25 in one run and +1.00 in the other. That does not show the coordination paid off.</a:t>
+            </a:r>
+          </a:p>
+        </p:txBody>
+      </p:sp>
+    </p:spTree>
+  </p:cSld>
+  <p:clrMapOvr>
+    <a:masterClrMapping/>
+  </p:clrMapOvr>
+</p:sld>
+</file>
+
+<file path=ppt/slides/slide13.xml><?xml version="1.0" encoding="utf-8"?>
+<p:sld xmlns:a="http://schemas.openxmlformats.org/drawingml/2006/main" xmlns:p="http://schemas.openxmlformats.org/presentationml/2006/main" xmlns:r="http://schemas.openxmlformats.org/officeDocument/2006/relationships">
+  <p:cSld>
+    <p:spTree>
+      <p:nvGrpSpPr>
+        <p:cNvPr id="1" name=""/>
+        <p:cNvGrpSpPr/>
+        <p:nvPr/>
+      </p:nvGrpSpPr>
+      <p:grpSpPr/>
+      <p:sp>
+        <p:nvSpPr>
+          <p:cNvPr id="2" name="TextBox 1"/>
+          <p:cNvSpPr txBox="1"/>
+          <p:nvPr/>
+        </p:nvSpPr>
+        <p:spPr>
+          <a:xfrm>
+            <a:off x="548640" y="365760"/>
+            <a:ext cx="11064240" cy="1005840"/>
+          </a:xfrm>
+          <a:prstGeom prst="rect">
+            <a:avLst/>
+          </a:prstGeom>
+          <a:noFill/>
+        </p:spPr>
+        <p:txBody>
+          <a:bodyPr wrap="square">
+            <a:spAutoFit/>
+          </a:bodyPr>
+          <a:lstStyle/>
+          <a:p>
+            <a:pPr>
+              <a:spcAft>
+                <a:spcPts val="1000"/>
+              </a:spcAft>
+            </a:pPr>
+            <a:r>
+              <a:rPr sz="3000" b="1">
+                <a:solidFill>
+                  <a:srgbClr val="1F3A5F"/>
+                </a:solidFill>
+                <a:latin typeface="Calibri"/>
+              </a:rPr>
+              <a:t>What the colluders actually did</a:t>
+            </a:r>
+          </a:p>
+        </p:txBody>
+      </p:sp>
+      <p:sp>
+        <p:nvSpPr>
+          <p:cNvPr id="3" name="TextBox 2"/>
+          <p:cNvSpPr txBox="1"/>
+          <p:nvPr/>
+        </p:nvSpPr>
+        <p:spPr>
+          <a:xfrm>
+            <a:off x="548640" y="1645920"/>
+            <a:ext cx="11064240" cy="4754880"/>
+          </a:xfrm>
+          <a:prstGeom prst="rect">
+            <a:avLst/>
+          </a:prstGeom>
+          <a:noFill/>
+        </p:spPr>
+        <p:txBody>
+          <a:bodyPr wrap="square">
+            <a:spAutoFit/>
+          </a:bodyPr>
+          <a:lstStyle/>
+          <a:p>
+            <a:pPr>
+              <a:spcAft>
+                <a:spcPts val="1000"/>
+              </a:spcAft>
+            </a:pPr>
+            <a:r>
+              <a:rPr sz="2200" b="0">
+                <a:solidFill>
+                  <a:srgbClr val="444444"/>
+                </a:solidFill>
+                <a:latin typeface="Calibri"/>
+              </a:rPr>
+              <a:t>From the private messages the detector never sees:</a:t>
+            </a:r>
+          </a:p>
+          <a:p>
+            <a:pPr>
+              <a:spcAft>
+                <a:spcPts val="1000"/>
+              </a:spcAft>
+            </a:pPr>
+            <a:r>
+              <a:rPr sz="2200" b="0">
+                <a:solidFill>
+                  <a:srgbClr val="444444"/>
+                </a:solidFill>
+                <a:latin typeface="Calibri"/>
+              </a:rPr>
+              <a:t/>
+            </a:r>
+          </a:p>
+          <a:p>
+            <a:pPr>
+              <a:spcAft>
+                <a:spcPts val="1000"/>
+              </a:spcAft>
+            </a:pPr>
+            <a:r>
+              <a:rPr sz="2200" b="0">
+                <a:solidFill>
+                  <a:srgbClr val="444444"/>
+                </a:solidFill>
+                <a:latin typeface="Calibri"/>
+              </a:rPr>
+              <a:t>"I'll play rock to beat your scissors, so I can score while you lose."</a:t>
+            </a:r>
+          </a:p>
+          <a:p>
+            <a:pPr>
+              <a:spcAft>
+                <a:spcPts val="1000"/>
+              </a:spcAft>
+            </a:pPr>
+            <a:r>
+              <a:rPr sz="2200" b="0">
+                <a:solidFill>
+                  <a:srgbClr val="444444"/>
+                </a:solidFill>
+                <a:latin typeface="Calibri"/>
+              </a:rPr>
+              <a:t/>
+            </a:r>
+          </a:p>
+          <a:p>
+            <a:pPr>
+              <a:spcAft>
+                <a:spcPts val="1000"/>
+              </a:spcAft>
+            </a:pPr>
+            <a:r>
+              <a:rPr sz="2200" b="0">
+                <a:solidFill>
+                  <a:srgbClr val="444444"/>
+                </a:solidFill>
+                <a:latin typeface="Calibri"/>
+              </a:rPr>
+              <a:t>One partner throws the round so the other scores. Same-action statistics miss this entirely; it looks like anti-correlation.</a:t>
+            </a:r>
+          </a:p>
+        </p:txBody>
+      </p:sp>
+    </p:spTree>
+  </p:cSld>
+  <p:clrMapOvr>
+    <a:masterClrMapping/>
+  </p:clrMapOvr>
+</p:sld>
+</file>
+
+<file path=ppt/slides/slide14.xml><?xml version="1.0" encoding="utf-8"?>
+<p:sld xmlns:a="http://schemas.openxmlformats.org/drawingml/2006/main" xmlns:p="http://schemas.openxmlformats.org/presentationml/2006/main" xmlns:r="http://schemas.openxmlformats.org/officeDocument/2006/relationships">
+  <p:cSld>
+    <p:spTree>
+      <p:nvGrpSpPr>
+        <p:cNvPr id="1" name=""/>
+        <p:cNvGrpSpPr/>
+        <p:nvPr/>
+      </p:nvGrpSpPr>
+      <p:grpSpPr/>
+      <p:sp>
+        <p:nvSpPr>
+          <p:cNvPr id="2" name="TextBox 1"/>
+          <p:cNvSpPr txBox="1"/>
+          <p:nvPr/>
+        </p:nvSpPr>
+        <p:spPr>
+          <a:xfrm>
+            <a:off x="548640" y="365760"/>
+            <a:ext cx="11064240" cy="1005840"/>
+          </a:xfrm>
+          <a:prstGeom prst="rect">
+            <a:avLst/>
+          </a:prstGeom>
+          <a:noFill/>
+        </p:spPr>
+        <p:txBody>
+          <a:bodyPr wrap="square">
+            <a:spAutoFit/>
+          </a:bodyPr>
+          <a:lstStyle/>
+          <a:p>
+            <a:pPr>
+              <a:spcAft>
+                <a:spcPts val="1000"/>
+              </a:spcAft>
+            </a:pPr>
+            <a:r>
+              <a:rPr sz="3000" b="1">
+                <a:solidFill>
+                  <a:srgbClr val="1F3A5F"/>
+                </a:solidFill>
+                <a:latin typeface="Calibri"/>
+              </a:rPr>
+              <a:t>Exploratory: reading the workspace</a:t>
+            </a:r>
+          </a:p>
+        </p:txBody>
+      </p:sp>
+      <p:pic>
+        <p:nvPicPr>
+          <p:cNvPr id="3" name="Picture 2" descr="fig_lens_assay.png"/>
+          <p:cNvPicPr>
+            <a:picLocks noChangeAspect="1"/>
+          </p:cNvPicPr>
+          <p:nvPr/>
+        </p:nvPicPr>
+        <p:blipFill>
+          <a:blip r:embed="rId2"/>
+          <a:stretch>
+            <a:fillRect/>
+          </a:stretch>
+        </p:blipFill>
+        <p:spPr>
+          <a:xfrm>
+            <a:off x="548640" y="1554480"/>
+            <a:ext cx="6766560" cy="3195320"/>
+          </a:xfrm>
+          <a:prstGeom prst="rect">
+            <a:avLst/>
+          </a:prstGeom>
+        </p:spPr>
+      </p:pic>
+      <p:sp>
+        <p:nvSpPr>
+          <p:cNvPr id="4" name="TextBox 3"/>
+          <p:cNvSpPr txBox="1"/>
+          <p:nvPr/>
+        </p:nvSpPr>
+        <p:spPr>
+          <a:xfrm>
+            <a:off x="7680960" y="1645920"/>
+            <a:ext cx="3931919" cy="4754880"/>
+          </a:xfrm>
+          <a:prstGeom prst="rect">
+            <a:avLst/>
+          </a:prstGeom>
+          <a:noFill/>
+        </p:spPr>
+        <p:txBody>
+          <a:bodyPr wrap="square">
+            <a:spAutoFit/>
+          </a:bodyPr>
+          <a:lstStyle/>
+          <a:p>
+            <a:pPr>
+              <a:spcAft>
+                <a:spcPts val="1000"/>
+              </a:spcAft>
+            </a:pPr>
+            <a:r>
+              <a:rPr sz="1700" b="0">
+                <a:solidFill>
+                  <a:srgbClr val="444444"/>
+                </a:solidFill>
+                <a:latin typeface="Calibri"/>
+              </a:rPr>
+              <a:t>gemma-4-12B-it receives a coded proposal from a partner.</a:t>
+            </a:r>
+          </a:p>
+          <a:p>
+            <a:pPr>
+              <a:spcAft>
+                <a:spcPts val="1000"/>
+              </a:spcAft>
+            </a:pPr>
+            <a:r>
+              <a:rPr sz="1700" b="0">
+                <a:solidFill>
+                  <a:srgbClr val="444444"/>
+                </a:solidFill>
+                <a:latin typeface="Calibri"/>
+              </a:rPr>
+              <a:t/>
+            </a:r>
+          </a:p>
+          <a:p>
+            <a:pPr>
+              <a:spcAft>
+                <a:spcPts val="1000"/>
+              </a:spcAft>
+            </a:pPr>
+            <a:r>
+              <a:rPr sz="1700" b="0">
+                <a:solidFill>
+                  <a:srgbClr val="444444"/>
+                </a:solidFill>
+                <a:latin typeface="Calibri"/>
+              </a:rPr>
+              <a:t>Does its internal representation differ between adopting and refusing?</a:t>
+            </a:r>
+          </a:p>
+          <a:p>
+            <a:pPr>
+              <a:spcAft>
+                <a:spcPts val="1000"/>
+              </a:spcAft>
+            </a:pPr>
+            <a:r>
+              <a:rPr sz="1700" b="0">
+                <a:solidFill>
+                  <a:srgbClr val="444444"/>
+                </a:solidFill>
+                <a:latin typeface="Calibri"/>
+              </a:rPr>
+              <a:t/>
+            </a:r>
+          </a:p>
+          <a:p>
+            <a:pPr>
+              <a:spcAft>
+                <a:spcPts val="1000"/>
+              </a:spcAft>
+            </a:pPr>
+            <a:r>
+              <a:rPr sz="1700" b="0">
+                <a:solidFill>
+                  <a:srgbClr val="444444"/>
+                </a:solidFill>
+                <a:latin typeface="Calibri"/>
+              </a:rPr>
+              <a:t>It never adopted an ineligible proposal, 30 of 30 times. So the question stays open.</a:t>
+            </a:r>
+          </a:p>
+          <a:p>
+            <a:pPr>
+              <a:spcAft>
+                <a:spcPts val="1000"/>
+              </a:spcAft>
+            </a:pPr>
+            <a:r>
+              <a:rPr sz="1700" b="0">
+                <a:solidFill>
+                  <a:srgbClr val="444444"/>
+                </a:solidFill>
+                <a:latin typeface="Calibri"/>
+              </a:rPr>
+              <a:t/>
+            </a:r>
+          </a:p>
+          <a:p>
+            <a:pPr>
+              <a:spcAft>
+                <a:spcPts val="1000"/>
+              </a:spcAft>
+            </a:pPr>
+            <a:r>
+              <a:rPr sz="1700" b="0">
+                <a:solidFill>
+                  <a:srgbClr val="444444"/>
+                </a:solidFill>
+                <a:latin typeface="Calibri"/>
+              </a:rPr>
+              <a:t>The item read out strongly when the model was about to act on it, and at chance when it declined. That is one lens at one position, and it does not show what the model contains.</a:t>
+            </a:r>
+          </a:p>
+        </p:txBody>
+      </p:sp>
+    </p:spTree>
+  </p:cSld>
+  <p:clrMapOvr>
+    <a:masterClrMapping/>
+  </p:clrMapOvr>
+</p:sld>
+</file>
+
+<file path=ppt/slides/slide15.xml><?xml version="1.0" encoding="utf-8"?>
+<p:sld xmlns:a="http://schemas.openxmlformats.org/drawingml/2006/main" xmlns:p="http://schemas.openxmlformats.org/presentationml/2006/main" xmlns:r="http://schemas.openxmlformats.org/officeDocument/2006/relationships">
+  <p:cSld>
+    <p:spTree>
+      <p:nvGrpSpPr>
+        <p:cNvPr id="1" name=""/>
+        <p:cNvGrpSpPr/>
+        <p:nvPr/>
+      </p:nvGrpSpPr>
+      <p:grpSpPr/>
+      <p:sp>
+        <p:nvSpPr>
+          <p:cNvPr id="2" name="TextBox 1"/>
+          <p:cNvSpPr txBox="1"/>
+          <p:nvPr/>
+        </p:nvSpPr>
+        <p:spPr>
+          <a:xfrm>
+            <a:off x="548640" y="365760"/>
+            <a:ext cx="11064240" cy="1005840"/>
+          </a:xfrm>
+          <a:prstGeom prst="rect">
+            <a:avLst/>
+          </a:prstGeom>
+          <a:noFill/>
+        </p:spPr>
+        <p:txBody>
+          <a:bodyPr wrap="square">
+            <a:spAutoFit/>
+          </a:bodyPr>
+          <a:lstStyle/>
+          <a:p>
+            <a:pPr>
+              <a:spcAft>
+                <a:spcPts val="1000"/>
+              </a:spcAft>
+            </a:pPr>
+            <a:r>
+              <a:rPr sz="3000" b="1">
+                <a:solidFill>
+                  <a:srgbClr val="1F3A5F"/>
+                </a:solidFill>
+                <a:latin typeface="Calibri"/>
+              </a:rPr>
+              <a:t>What an auditor should check</a:t>
+            </a:r>
+          </a:p>
+        </p:txBody>
+      </p:sp>
+      <p:sp>
+        <p:nvSpPr>
+          <p:cNvPr id="3" name="TextBox 2"/>
+          <p:cNvSpPr txBox="1"/>
+          <p:nvPr/>
+        </p:nvSpPr>
+        <p:spPr>
+          <a:xfrm>
+            <a:off x="548640" y="1645920"/>
+            <a:ext cx="11064240" cy="4754880"/>
+          </a:xfrm>
+          <a:prstGeom prst="rect">
+            <a:avLst/>
+          </a:prstGeom>
+          <a:noFill/>
+        </p:spPr>
+        <p:txBody>
+          <a:bodyPr wrap="square">
+            <a:spAutoFit/>
+          </a:bodyPr>
+          <a:lstStyle/>
+          <a:p>
+            <a:pPr>
+              <a:spcAft>
+                <a:spcPts val="1000"/>
+              </a:spcAft>
+            </a:pPr>
+            <a:r>
+              <a:rPr sz="2200" b="0">
+                <a:solidFill>
+                  <a:srgbClr val="444444"/>
+                </a:solidFill>
+                <a:latin typeface="Calibri"/>
+              </a:rPr>
+              <a:t>Is the conditioning state as rich as any rule the agents could innocently follow?</a:t>
+            </a:r>
+          </a:p>
+          <a:p>
+            <a:pPr>
+              <a:spcAft>
+                <a:spcPts val="1000"/>
+              </a:spcAft>
+            </a:pPr>
+            <a:r>
+              <a:rPr sz="2200" b="0">
+                <a:solidFill>
+                  <a:srgbClr val="444444"/>
+                </a:solidFill>
+                <a:latin typeface="Calibri"/>
+              </a:rPr>
+              <a:t/>
+            </a:r>
+          </a:p>
+          <a:p>
+            <a:pPr>
+              <a:spcAft>
+                <a:spcPts val="1000"/>
+              </a:spcAft>
+            </a:pPr>
+            <a:r>
+              <a:rPr sz="2200" b="0">
+                <a:solidFill>
+                  <a:srgbClr val="444444"/>
+                </a:solidFill>
+                <a:latin typeface="Calibri"/>
+              </a:rPr>
+              <a:t>Is the decision rule calibrated on a null that matches the agents?</a:t>
+            </a:r>
+          </a:p>
+          <a:p>
+            <a:pPr>
+              <a:spcAft>
+                <a:spcPts val="1000"/>
+              </a:spcAft>
+            </a:pPr>
+            <a:r>
+              <a:rPr sz="2200" b="0">
+                <a:solidFill>
+                  <a:srgbClr val="444444"/>
+                </a:solidFill>
+                <a:latin typeface="Calibri"/>
+              </a:rPr>
+              <a:t/>
+            </a:r>
+          </a:p>
+          <a:p>
+            <a:pPr>
+              <a:spcAft>
+                <a:spcPts val="1000"/>
+              </a:spcAft>
+            </a:pPr>
+            <a:r>
+              <a:rPr sz="2200" b="0">
+                <a:solidFill>
+                  <a:srgbClr val="444444"/>
+                </a:solidFill>
+                <a:latin typeface="Calibri"/>
+              </a:rPr>
+              <a:t>Could the coalition have more than two members?</a:t>
+            </a:r>
+          </a:p>
+          <a:p>
+            <a:pPr>
+              <a:spcAft>
+                <a:spcPts val="1000"/>
+              </a:spcAft>
+            </a:pPr>
+            <a:r>
+              <a:rPr sz="2200" b="0">
+                <a:solidFill>
+                  <a:srgbClr val="444444"/>
+                </a:solidFill>
+                <a:latin typeface="Calibri"/>
+              </a:rPr>
+              <a:t/>
+            </a:r>
+          </a:p>
+          <a:p>
+            <a:pPr>
+              <a:spcAft>
+                <a:spcPts val="1000"/>
+              </a:spcAft>
+            </a:pPr>
+            <a:r>
+              <a:rPr sz="2200" b="0">
+                <a:solidFill>
+                  <a:srgbClr val="444444"/>
+                </a:solidFill>
+                <a:latin typeface="Calibri"/>
+              </a:rPr>
+              <a:t>Is the claim about ranking, about a threshold, or about harm? They are different numbers.</a:t>
+            </a:r>
+          </a:p>
+        </p:txBody>
+      </p:sp>
+    </p:spTree>
+  </p:cSld>
+  <p:clrMapOvr>
+    <a:masterClrMapping/>
+  </p:clrMapOvr>
+</p:sld>
+</file>
+
+<file path=ppt/slides/slide16.xml><?xml version="1.0" encoding="utf-8"?>
+<p:sld xmlns:a="http://schemas.openxmlformats.org/drawingml/2006/main" xmlns:p="http://schemas.openxmlformats.org/presentationml/2006/main" xmlns:r="http://schemas.openxmlformats.org/officeDocument/2006/relationships">
+  <p:cSld>
+    <p:spTree>
+      <p:nvGrpSpPr>
+        <p:cNvPr id="1" name=""/>
+        <p:cNvGrpSpPr/>
+        <p:nvPr/>
+      </p:nvGrpSpPr>
+      <p:grpSpPr/>
+      <p:sp>
+        <p:nvSpPr>
+          <p:cNvPr id="2" name="TextBox 1"/>
+          <p:cNvSpPr txBox="1"/>
+          <p:nvPr/>
+        </p:nvSpPr>
+        <p:spPr>
+          <a:xfrm>
+            <a:off x="548640" y="365760"/>
+            <a:ext cx="11064240" cy="1005840"/>
+          </a:xfrm>
+          <a:prstGeom prst="rect">
+            <a:avLst/>
+          </a:prstGeom>
+          <a:noFill/>
+        </p:spPr>
+        <p:txBody>
+          <a:bodyPr wrap="square">
+            <a:spAutoFit/>
+          </a:bodyPr>
+          <a:lstStyle/>
+          <a:p>
+            <a:pPr>
+              <a:spcAft>
+                <a:spcPts val="1000"/>
+              </a:spcAft>
+            </a:pPr>
+            <a:r>
+              <a:rPr sz="3000" b="1">
+                <a:solidFill>
+                  <a:srgbClr val="1F3A5F"/>
+                </a:solidFill>
+                <a:latin typeface="Calibri"/>
+              </a:rPr>
+              <a:t>What is and is not new</a:t>
+            </a:r>
+          </a:p>
+        </p:txBody>
+      </p:sp>
+      <p:sp>
+        <p:nvSpPr>
+          <p:cNvPr id="3" name="TextBox 2"/>
+          <p:cNvSpPr txBox="1"/>
+          <p:nvPr/>
+        </p:nvSpPr>
+        <p:spPr>
+          <a:xfrm>
+            <a:off x="548640" y="1645920"/>
+            <a:ext cx="11064240" cy="4754880"/>
+          </a:xfrm>
+          <a:prstGeom prst="rect">
+            <a:avLst/>
+          </a:prstGeom>
+          <a:noFill/>
+        </p:spPr>
+        <p:txBody>
+          <a:bodyPr wrap="square">
+            <a:spAutoFit/>
+          </a:bodyPr>
+          <a:lstStyle/>
+          <a:p>
+            <a:pPr>
+              <a:spcAft>
+                <a:spcPts val="1000"/>
+              </a:spcAft>
+            </a:pPr>
+            <a:r>
+              <a:rPr sz="2200" b="0">
+                <a:solidFill>
+                  <a:srgbClr val="444444"/>
+                </a:solidFill>
+                <a:latin typeface="Calibri"/>
+              </a:rPr>
+              <a:t>New: a general-N implementation with a permutation null; the four evaluation axes together; the algebra of coalition cancellation; two decision rules run on the same LLM logs.</a:t>
+            </a:r>
+          </a:p>
+          <a:p>
+            <a:pPr>
+              <a:spcAft>
+                <a:spcPts val="1000"/>
+              </a:spcAft>
+            </a:pPr>
+            <a:r>
+              <a:rPr sz="2200" b="0">
+                <a:solidFill>
+                  <a:srgbClr val="444444"/>
+                </a:solidFill>
+                <a:latin typeface="Calibri"/>
+              </a:rPr>
+              <a:t/>
+            </a:r>
+          </a:p>
+          <a:p>
+            <a:pPr>
+              <a:spcAft>
+                <a:spcPts val="1000"/>
+              </a:spcAft>
+            </a:pPr>
+            <a:r>
+              <a:rPr sz="2200" b="0">
+                <a:solidFill>
+                  <a:srgbClr val="444444"/>
+                </a:solidFill>
+                <a:latin typeface="Calibri"/>
+              </a:rPr>
+              <a:t>Not new: the statistic, conditioning on state, permutation calibration, scripted evaluation, same-model correlation.</a:t>
+            </a:r>
+          </a:p>
+          <a:p>
+            <a:pPr>
+              <a:spcAft>
+                <a:spcPts val="1000"/>
+              </a:spcAft>
+            </a:pPr>
+            <a:r>
+              <a:rPr sz="2200" b="0">
+                <a:solidFill>
+                  <a:srgbClr val="444444"/>
+                </a:solidFill>
+                <a:latin typeface="Calibri"/>
+              </a:rPr>
+              <a:t/>
+            </a:r>
+          </a:p>
+          <a:p>
+            <a:pPr>
+              <a:spcAft>
+                <a:spcPts val="1000"/>
+              </a:spcAft>
+            </a:pPr>
+            <a:r>
+              <a:rPr sz="2200" b="0">
+                <a:solidFill>
+                  <a:srgbClr val="444444"/>
+                </a:solidFill>
+                <a:latin typeface="Calibri"/>
+              </a:rPr>
+              <a:t>Code, logs and notebooks are in the repository.</a:t>
+            </a:r>
+          </a:p>
+        </p:txBody>
+      </p:sp>
+      <p:sp>
+        <p:nvSpPr>
+          <p:cNvPr id="4" name="TextBox 3"/>
+          <p:cNvSpPr txBox="1"/>
+          <p:nvPr/>
+        </p:nvSpPr>
+        <p:spPr>
+          <a:xfrm>
+            <a:off x="548640" y="6217920"/>
+            <a:ext cx="11064240" cy="457200"/>
+          </a:xfrm>
+          <a:prstGeom prst="rect">
+            <a:avLst/>
+          </a:prstGeom>
+          <a:noFill/>
+        </p:spPr>
+        <p:txBody>
+          <a:bodyPr wrap="square">
+            <a:spAutoFit/>
+          </a:bodyPr>
+          <a:lstStyle/>
+          <a:p>
+            <a:pPr>
+              <a:spcAft>
+                <a:spcPts val="1000"/>
+              </a:spcAft>
+            </a:pPr>
+            <a:r>
+              <a:rPr sz="1300" b="0">
+                <a:solidFill>
+                  <a:srgbClr val="D9822B"/>
                 </a:solidFill>
                 <a:latin typeface="Calibri"/>
               </a:rPr>
@@ -3250,8 +4613,8 @@
         </p:nvSpPr>
         <p:spPr>
           <a:xfrm>
-            <a:off x="457200" y="274320"/>
-            <a:ext cx="11247120" cy="822960"/>
+            <a:off x="548640" y="365760"/>
+            <a:ext cx="11064240" cy="1005840"/>
           </a:xfrm>
           <a:prstGeom prst="rect">
             <a:avLst/>
@@ -3264,7 +4627,11 @@
           </a:bodyPr>
           <a:lstStyle/>
           <a:p>
-            <a:pPr algn="l"/>
+            <a:pPr>
+              <a:spcAft>
+                <a:spcPts val="1000"/>
+              </a:spcAft>
+            </a:pPr>
             <a:r>
               <a:rPr sz="3000" b="1">
                 <a:solidFill>
@@ -3272,7 +4639,7 @@
                 </a:solidFill>
                 <a:latin typeface="Calibri"/>
               </a:rPr>
-              <a:t>When does statistical dependence count as evidence of collusion?</a:t>
+              <a:t>The question</a:t>
             </a:r>
           </a:p>
         </p:txBody>
@@ -3285,8 +4652,8 @@
         </p:nvSpPr>
         <p:spPr>
           <a:xfrm>
-            <a:off x="548640" y="1463040"/>
-            <a:ext cx="5760720" cy="5029200"/>
+            <a:off x="548640" y="1645920"/>
+            <a:ext cx="11064240" cy="4754880"/>
           </a:xfrm>
           <a:prstGeom prst="rect">
             <a:avLst/>
@@ -3299,91 +4666,87 @@
           </a:bodyPr>
           <a:lstStyle/>
           <a:p>
-            <a:pPr algn="l"/>
-            <a:r>
-              <a:rPr sz="1700" b="0">
-                <a:solidFill>
-                  <a:srgbClr val="555555"/>
-                </a:solidFill>
-                <a:latin typeface="Calibri"/>
-              </a:rPr>
-              <a:t>•  Antitrust rule: parallel conduct is not an agreement. Auditors need a plus factor.</a:t>
-            </a:r>
-          </a:p>
-          <a:p>
-            <a:pPr algn="l"/>
-            <a:r>
-              <a:rPr sz="1700" b="0">
-                <a:solidFill>
-                  <a:srgbClr val="555555"/>
-                </a:solidFill>
-                <a:latin typeface="Calibri"/>
-              </a:rPr>
-              <a:t>•  Pairwise net influence (Bonjour et al. 2022): dependence between two agents' actions given the public state, minus the strongest third-party dependence. Action logs only.</a:t>
-            </a:r>
-          </a:p>
-          <a:p>
-            <a:pPr algn="l"/>
-            <a:r>
-              <a:rPr sz="1700" b="0">
-                <a:solidFill>
-                  <a:srgbClr val="555555"/>
-                </a:solidFill>
-                <a:latin typeface="Calibri"/>
-              </a:rPr>
-              <a:t>•  We ask: under which assumptions about public information, sample size and coalition structure does it separate planted coordination from innocent dependence?</a:t>
-            </a:r>
-          </a:p>
-          <a:p>
-            <a:pPr algn="l"/>
-            <a:r>
-              <a:rPr sz="1700" b="0">
-                <a:solidFill>
-                  <a:srgbClr val="555555"/>
-                </a:solidFill>
-                <a:latin typeface="Calibri"/>
-              </a:rPr>
-              <a:t>•  7,400 scripted games with ground truth, two GPT-4.1-mini pilot runs (30 games each), one exploratory Jacobian-lens assay.</a:t>
-            </a:r>
-          </a:p>
-          <a:p>
-            <a:pPr algn="l"/>
-            <a:r>
-              <a:rPr sz="1700" b="0">
-                <a:solidFill>
-                  <a:srgbClr val="555555"/>
-                </a:solidFill>
-                <a:latin typeface="Calibri"/>
-              </a:rPr>
-              <a:t>•  Four findings. Each is an assumption an auditor must check before trusting a verdict.</a:t>
-            </a:r>
-          </a:p>
-        </p:txBody>
-      </p:sp>
-      <p:pic>
-        <p:nvPicPr>
-          <p:cNvPr id="4" name="Picture 3" descr="fig_evidence_ladder.png"/>
-          <p:cNvPicPr>
-            <a:picLocks noChangeAspect="1"/>
-          </p:cNvPicPr>
-          <p:nvPr/>
-        </p:nvPicPr>
-        <p:blipFill>
-          <a:blip r:embed="rId2"/>
-          <a:stretch>
-            <a:fillRect/>
-          </a:stretch>
-        </p:blipFill>
-        <p:spPr>
-          <a:xfrm>
-            <a:off x="6492240" y="1554480"/>
-            <a:ext cx="5394960" cy="3296920"/>
-          </a:xfrm>
-          <a:prstGeom prst="rect">
-            <a:avLst/>
-          </a:prstGeom>
-        </p:spPr>
-      </p:pic>
+            <a:pPr>
+              <a:spcAft>
+                <a:spcPts val="1000"/>
+              </a:spcAft>
+            </a:pPr>
+            <a:r>
+              <a:rPr sz="2200" b="0">
+                <a:solidFill>
+                  <a:srgbClr val="444444"/>
+                </a:solidFill>
+                <a:latin typeface="Calibri"/>
+              </a:rPr>
+              <a:t>Two AI agents act in a correlated way.</a:t>
+            </a:r>
+          </a:p>
+          <a:p>
+            <a:pPr>
+              <a:spcAft>
+                <a:spcPts val="1000"/>
+              </a:spcAft>
+            </a:pPr>
+            <a:r>
+              <a:rPr sz="2200" b="0">
+                <a:solidFill>
+                  <a:srgbClr val="444444"/>
+                </a:solidFill>
+                <a:latin typeface="Calibri"/>
+              </a:rPr>
+              <a:t/>
+            </a:r>
+          </a:p>
+          <a:p>
+            <a:pPr>
+              <a:spcAft>
+                <a:spcPts val="1000"/>
+              </a:spcAft>
+            </a:pPr>
+            <a:r>
+              <a:rPr sz="2200" b="0">
+                <a:solidFill>
+                  <a:srgbClr val="444444"/>
+                </a:solidFill>
+                <a:latin typeface="Calibri"/>
+              </a:rPr>
+              <a:t>Is that evidence they are colluding?</a:t>
+            </a:r>
+          </a:p>
+          <a:p>
+            <a:pPr>
+              <a:spcAft>
+                <a:spcPts val="1000"/>
+              </a:spcAft>
+            </a:pPr>
+            <a:r>
+              <a:rPr sz="2200" b="0">
+                <a:solidFill>
+                  <a:srgbClr val="444444"/>
+                </a:solidFill>
+                <a:latin typeface="Calibri"/>
+              </a:rPr>
+              <a:t/>
+            </a:r>
+          </a:p>
+          <a:p>
+            <a:pPr>
+              <a:spcAft>
+                <a:spcPts val="1000"/>
+              </a:spcAft>
+            </a:pPr>
+            <a:r>
+              <a:rPr sz="2200" b="0">
+                <a:solidFill>
+                  <a:srgbClr val="444444"/>
+                </a:solidFill>
+                <a:latin typeface="Calibri"/>
+              </a:rPr>
+              <a:t>Antitrust law says no: parallel conduct is not an agreement. Something more is needed, a plus factor.</a:t>
+            </a:r>
+          </a:p>
+        </p:txBody>
+      </p:sp>
     </p:spTree>
   </p:cSld>
   <p:clrMapOvr>
@@ -3410,8 +4773,8 @@
         </p:nvSpPr>
         <p:spPr>
           <a:xfrm>
-            <a:off x="457200" y="274320"/>
-            <a:ext cx="11247120" cy="822960"/>
+            <a:off x="548640" y="365760"/>
+            <a:ext cx="11064240" cy="1005840"/>
           </a:xfrm>
           <a:prstGeom prst="rect">
             <a:avLst/>
@@ -3424,7 +4787,11 @@
           </a:bodyPr>
           <a:lstStyle/>
           <a:p>
-            <a:pPr algn="l"/>
+            <a:pPr>
+              <a:spcAft>
+                <a:spcPts val="1000"/>
+              </a:spcAft>
+            </a:pPr>
             <a:r>
               <a:rPr sz="3000" b="1">
                 <a:solidFill>
@@ -3432,7 +4799,7 @@
                 </a:solidFill>
                 <a:latin typeface="Calibri"/>
               </a:rPr>
-              <a:t>Finding 1: conditioning on the wrong public state confidently names an innocent pair</a:t>
+              <a:t>The detector we test</a:t>
             </a:r>
           </a:p>
         </p:txBody>
@@ -3445,8 +4812,8 @@
         </p:nvSpPr>
         <p:spPr>
           <a:xfrm>
-            <a:off x="457200" y="960120"/>
-            <a:ext cx="11247120" cy="548640"/>
+            <a:off x="548640" y="1645920"/>
+            <a:ext cx="11064240" cy="4754880"/>
           </a:xfrm>
           <a:prstGeom prst="rect">
             <a:avLst/>
@@ -3459,110 +4826,115 @@
           </a:bodyPr>
           <a:lstStyle/>
           <a:p>
-            <a:pPr algn="l"/>
-            <a:r>
-              <a:rPr sz="1600" b="0">
-                <a:solidFill>
-                  <a:srgbClr val="555555"/>
-                </a:solidFill>
-                <a:latin typeface="Calibri"/>
-              </a:rPr>
-              <a:t>Two non-colluders following the same public rule (beat last round's majority) are perfectly correlated without any agreement</a:t>
-            </a:r>
-          </a:p>
-        </p:txBody>
-      </p:sp>
-      <p:pic>
-        <p:nvPicPr>
-          <p:cNvPr id="4" name="Picture 3" descr="fig_scripted.png"/>
-          <p:cNvPicPr>
-            <a:picLocks noChangeAspect="1"/>
-          </p:cNvPicPr>
-          <p:nvPr/>
-        </p:nvPicPr>
-        <p:blipFill>
-          <a:blip r:embed="rId2"/>
-          <a:stretch>
-            <a:fillRect/>
-          </a:stretch>
-        </p:blipFill>
-        <p:spPr>
-          <a:xfrm>
-            <a:off x="457200" y="1645920"/>
-            <a:ext cx="7498079" cy="2624328"/>
-          </a:xfrm>
-          <a:prstGeom prst="rect">
-            <a:avLst/>
-          </a:prstGeom>
-        </p:spPr>
-      </p:pic>
-      <p:sp>
-        <p:nvSpPr>
-          <p:cNvPr id="5" name="TextBox 4"/>
-          <p:cNvSpPr txBox="1"/>
-          <p:nvPr/>
-        </p:nvSpPr>
-        <p:spPr>
-          <a:xfrm>
-            <a:off x="8138160" y="1737360"/>
-            <a:ext cx="3749039" cy="4846320"/>
-          </a:xfrm>
-          <a:prstGeom prst="rect">
-            <a:avLst/>
-          </a:prstGeom>
-          <a:noFill/>
-        </p:spPr>
-        <p:txBody>
-          <a:bodyPr wrap="square">
-            <a:spAutoFit/>
-          </a:bodyPr>
-          <a:lstStyle/>
-          <a:p>
-            <a:pPr algn="l"/>
-            <a:r>
-              <a:rPr sz="1400" b="0">
-                <a:solidFill>
-                  <a:srgbClr val="555555"/>
-                </a:solidFill>
-                <a:latin typeface="Calibri"/>
-              </a:rPr>
-              <a:t>•  Unconditioned statistics (memoryless net influence, raw MI, Cramer's V, same-action rate) rank the innocent pair first in 96 to 100% of games.</a:t>
-            </a:r>
-          </a:p>
-          <a:p>
-            <a:pPr algn="l"/>
-            <a:r>
-              <a:rPr sz="1400" b="0">
-                <a:solidFill>
-                  <a:srgbClr val="555555"/>
-                </a:solidFill>
-                <a:latin typeface="Calibri"/>
-              </a:rPr>
-              <a:t>•  Condition on the previous majority: true pair ranked first in 98 to 100%, innocent pair never flagged.</a:t>
-            </a:r>
-          </a:p>
-          <a:p>
-            <a:pPr algn="l"/>
-            <a:r>
-              <a:rPr sz="1400" b="0">
-                <a:solidFill>
-                  <a:srgbClr val="555555"/>
-                </a:solidFill>
-                <a:latin typeface="Calibri"/>
-              </a:rPr>
-              <a:t>•  But an innocent rule keyed on a richer state (parallel_rich) defeats majority conditioning in 100% of games; the fixed rule flags it in 65 to 100% of no-collusion games.</a:t>
-            </a:r>
-          </a:p>
-          <a:p>
-            <a:pPr algn="l"/>
-            <a:r>
-              <a:rPr sz="1400" b="0">
-                <a:solidFill>
-                  <a:srgbClr val="555555"/>
-                </a:solidFill>
-                <a:latin typeface="Calibri"/>
-              </a:rPr>
-              <a:t>•  Profile-state conditioning works only once T is large relative to the number of states.</a:t>
+            <a:pPr>
+              <a:spcAft>
+                <a:spcPts val="1000"/>
+              </a:spcAft>
+            </a:pPr>
+            <a:r>
+              <a:rPr sz="2200" b="0">
+                <a:solidFill>
+                  <a:srgbClr val="444444"/>
+                </a:solidFill>
+                <a:latin typeface="Calibri"/>
+              </a:rPr>
+              <a:t>Pairwise net influence (Bonjour et al. 2022).</a:t>
+            </a:r>
+          </a:p>
+          <a:p>
+            <a:pPr>
+              <a:spcAft>
+                <a:spcPts val="1000"/>
+              </a:spcAft>
+            </a:pPr>
+            <a:r>
+              <a:rPr sz="2200" b="0">
+                <a:solidFill>
+                  <a:srgbClr val="444444"/>
+                </a:solidFill>
+                <a:latin typeface="Calibri"/>
+              </a:rPr>
+              <a:t/>
+            </a:r>
+          </a:p>
+          <a:p>
+            <a:pPr>
+              <a:spcAft>
+                <a:spcPts val="1000"/>
+              </a:spcAft>
+            </a:pPr>
+            <a:r>
+              <a:rPr sz="2200" b="0">
+                <a:solidFill>
+                  <a:srgbClr val="444444"/>
+                </a:solidFill>
+                <a:latin typeface="Calibri"/>
+              </a:rPr>
+              <a:t>Measure how much two agents' actions depend on each other, given the public state of the game.</a:t>
+            </a:r>
+          </a:p>
+          <a:p>
+            <a:pPr>
+              <a:spcAft>
+                <a:spcPts val="1000"/>
+              </a:spcAft>
+            </a:pPr>
+            <a:r>
+              <a:rPr sz="2200" b="0">
+                <a:solidFill>
+                  <a:srgbClr val="444444"/>
+                </a:solidFill>
+                <a:latin typeface="Calibri"/>
+              </a:rPr>
+              <a:t/>
+            </a:r>
+          </a:p>
+          <a:p>
+            <a:pPr>
+              <a:spcAft>
+                <a:spcPts val="1000"/>
+              </a:spcAft>
+            </a:pPr>
+            <a:r>
+              <a:rPr sz="2200" b="0">
+                <a:solidFill>
+                  <a:srgbClr val="444444"/>
+                </a:solidFill>
+                <a:latin typeface="Calibri"/>
+              </a:rPr>
+              <a:t>Subtract the strongest dependence any third agent has on the same target.</a:t>
+            </a:r>
+          </a:p>
+          <a:p>
+            <a:pPr>
+              <a:spcAft>
+                <a:spcPts val="1000"/>
+              </a:spcAft>
+            </a:pPr>
+            <a:r>
+              <a:rPr sz="2200" b="0">
+                <a:solidFill>
+                  <a:srgbClr val="444444"/>
+                </a:solidFill>
+                <a:latin typeface="Calibri"/>
+              </a:rPr>
+              <a:t/>
+            </a:r>
+          </a:p>
+          <a:p>
+            <a:pPr>
+              <a:spcAft>
+                <a:spcPts val="1000"/>
+              </a:spcAft>
+            </a:pPr>
+            <a:r>
+              <a:rPr sz="2200" b="0">
+                <a:solidFill>
+                  <a:srgbClr val="444444"/>
+                </a:solidFill>
+                <a:latin typeface="Calibri"/>
+              </a:rPr>
+              <a:t>If what is left is above a threshold, call the pair colluding. Action logs only, no messages.</a:t>
             </a:r>
           </a:p>
         </p:txBody>
@@ -3593,8 +4965,8 @@
         </p:nvSpPr>
         <p:spPr>
           <a:xfrm>
-            <a:off x="457200" y="274320"/>
-            <a:ext cx="11247120" cy="822960"/>
+            <a:off x="548640" y="365760"/>
+            <a:ext cx="11064240" cy="1005840"/>
           </a:xfrm>
           <a:prstGeom prst="rect">
             <a:avLst/>
@@ -3607,7 +4979,11 @@
           </a:bodyPr>
           <a:lstStyle/>
           <a:p>
-            <a:pPr algn="l"/>
+            <a:pPr>
+              <a:spcAft>
+                <a:spcPts val="1000"/>
+              </a:spcAft>
+            </a:pPr>
             <a:r>
               <a:rPr sz="3000" b="1">
                 <a:solidFill>
@@ -3615,7 +4991,7 @@
                 </a:solidFill>
                 <a:latin typeface="Calibri"/>
               </a:rPr>
-              <a:t>Finding 2: removing estimation bias is not controlling false positives</a:t>
+              <a:t>What we did</a:t>
             </a:r>
           </a:p>
         </p:txBody>
@@ -3628,8 +5004,8 @@
         </p:nvSpPr>
         <p:spPr>
           <a:xfrm>
-            <a:off x="457200" y="960120"/>
-            <a:ext cx="11247120" cy="548640"/>
+            <a:off x="548640" y="1645920"/>
+            <a:ext cx="11064240" cy="4754880"/>
           </a:xfrm>
           <a:prstGeom prst="rect">
             <a:avLst/>
@@ -3642,110 +5018,115 @@
           </a:bodyPr>
           <a:lstStyle/>
           <a:p>
-            <a:pPr algn="l"/>
-            <a:r>
-              <a:rPr sz="1600" b="0">
-                <a:solidFill>
-                  <a:srgbClr val="555555"/>
-                </a:solidFill>
-                <a:latin typeface="Calibri"/>
-              </a:rPr>
-              <a:t>Plug-in MI bias at 25 rounds (about 0.08 nats) exceeds the published threshold of 0.05</a:t>
-            </a:r>
-          </a:p>
-        </p:txBody>
-      </p:sp>
-      <p:pic>
-        <p:nvPicPr>
-          <p:cNvPr id="4" name="Picture 3" descr="fig_extensions.png"/>
-          <p:cNvPicPr>
-            <a:picLocks noChangeAspect="1"/>
-          </p:cNvPicPr>
-          <p:nvPr/>
-        </p:nvPicPr>
-        <p:blipFill>
-          <a:blip r:embed="rId2"/>
-          <a:stretch>
-            <a:fillRect/>
-          </a:stretch>
-        </p:blipFill>
-        <p:spPr>
-          <a:xfrm>
-            <a:off x="457200" y="1645920"/>
-            <a:ext cx="7498079" cy="2225236"/>
-          </a:xfrm>
-          <a:prstGeom prst="rect">
-            <a:avLst/>
-          </a:prstGeom>
-        </p:spPr>
-      </p:pic>
-      <p:sp>
-        <p:nvSpPr>
-          <p:cNvPr id="5" name="TextBox 4"/>
-          <p:cNvSpPr txBox="1"/>
-          <p:nvPr/>
-        </p:nvSpPr>
-        <p:spPr>
-          <a:xfrm>
-            <a:off x="8138160" y="1737360"/>
-            <a:ext cx="3749039" cy="4846320"/>
-          </a:xfrm>
-          <a:prstGeom prst="rect">
-            <a:avLst/>
-          </a:prstGeom>
-          <a:noFill/>
-        </p:spPr>
-        <p:txBody>
-          <a:bodyPr wrap="square">
-            <a:spAutoFit/>
-          </a:bodyPr>
-          <a:lstStyle/>
-          <a:p>
-            <a:pPr algn="l"/>
-            <a:r>
-              <a:rPr sz="1400" b="0">
-                <a:solidFill>
-                  <a:srgbClr val="555555"/>
-                </a:solidFill>
-                <a:latin typeface="Calibri"/>
-              </a:rPr>
-              <a:t>•  Fixed threshold, corrected: still fires in about half of all-random 25-round games.</a:t>
-            </a:r>
-          </a:p>
-          <a:p>
-            <a:pPr algn="l"/>
-            <a:r>
-              <a:rPr sz="1400" b="0">
-                <a:solidFill>
-                  <a:srgbClr val="555555"/>
-                </a:solidFill>
-                <a:latin typeface="Calibri"/>
-              </a:rPr>
-              <a:t>•  Holm permutation rule: 3 to 6% on scripted nulls, never names the innocent pair. Power at 25 rounds drops to 0.42.</a:t>
-            </a:r>
-          </a:p>
-          <a:p>
-            <a:pPr algn="l"/>
-            <a:r>
-              <a:rPr sz="1400" b="0">
-                <a:solidFill>
-                  <a:srgbClr val="555555"/>
-                </a:solidFill>
-                <a:latin typeface="Calibri"/>
-              </a:rPr>
-              <a:t>•  Transfer: on the pooled GPT-4.1-mini control with no planted coalition, the Holm rule flags a pair at Holm p = 0.012 in both runs.</a:t>
-            </a:r>
-          </a:p>
-          <a:p>
-            <a:pPr algn="l"/>
-            <a:r>
-              <a:rPr sz="1400" b="0">
-                <a:solidFill>
-                  <a:srgbClr val="555555"/>
-                </a:solidFill>
-                <a:latin typeface="Calibri"/>
-              </a:rPr>
-              <a:t>•  Rejecting conditional independence is a statement about a null; it is not establishing collusion.</a:t>
+            <a:pPr>
+              <a:spcAft>
+                <a:spcPts val="1000"/>
+              </a:spcAft>
+            </a:pPr>
+            <a:r>
+              <a:rPr sz="2200" b="0">
+                <a:solidFill>
+                  <a:srgbClr val="444444"/>
+                </a:solidFill>
+                <a:latin typeface="Calibri"/>
+              </a:rPr>
+              <a:t>7,400 scripted Rock-Paper-Scissors games with a planted colluding pair, so we know the truth.</a:t>
+            </a:r>
+          </a:p>
+          <a:p>
+            <a:pPr>
+              <a:spcAft>
+                <a:spcPts val="1000"/>
+              </a:spcAft>
+            </a:pPr>
+            <a:r>
+              <a:rPr sz="2200" b="0">
+                <a:solidFill>
+                  <a:srgbClr val="444444"/>
+                </a:solidFill>
+                <a:latin typeface="Calibri"/>
+              </a:rPr>
+              <a:t/>
+            </a:r>
+          </a:p>
+          <a:p>
+            <a:pPr>
+              <a:spcAft>
+                <a:spcPts val="1000"/>
+              </a:spcAft>
+            </a:pPr>
+            <a:r>
+              <a:rPr sz="2200" b="0">
+                <a:solidFill>
+                  <a:srgbClr val="444444"/>
+                </a:solidFill>
+                <a:latin typeface="Calibri"/>
+              </a:rPr>
+              <a:t>Two runs of GPT-4.1-mini agents, 30 games each, with and without a hidden private channel.</a:t>
+            </a:r>
+          </a:p>
+          <a:p>
+            <a:pPr>
+              <a:spcAft>
+                <a:spcPts val="1000"/>
+              </a:spcAft>
+            </a:pPr>
+            <a:r>
+              <a:rPr sz="2200" b="0">
+                <a:solidFill>
+                  <a:srgbClr val="444444"/>
+                </a:solidFill>
+                <a:latin typeface="Calibri"/>
+              </a:rPr>
+              <a:t/>
+            </a:r>
+          </a:p>
+          <a:p>
+            <a:pPr>
+              <a:spcAft>
+                <a:spcPts val="1000"/>
+              </a:spcAft>
+            </a:pPr>
+            <a:r>
+              <a:rPr sz="2200" b="0">
+                <a:solidFill>
+                  <a:srgbClr val="444444"/>
+                </a:solidFill>
+                <a:latin typeface="Calibri"/>
+              </a:rPr>
+              <a:t>One exploratory experiment reading a model's internal workspace.</a:t>
+            </a:r>
+          </a:p>
+          <a:p>
+            <a:pPr>
+              <a:spcAft>
+                <a:spcPts val="1000"/>
+              </a:spcAft>
+            </a:pPr>
+            <a:r>
+              <a:rPr sz="2200" b="0">
+                <a:solidFill>
+                  <a:srgbClr val="444444"/>
+                </a:solidFill>
+                <a:latin typeface="Calibri"/>
+              </a:rPr>
+              <a:t/>
+            </a:r>
+          </a:p>
+          <a:p>
+            <a:pPr>
+              <a:spcAft>
+                <a:spcPts val="1000"/>
+              </a:spcAft>
+            </a:pPr>
+            <a:r>
+              <a:rPr sz="2200" b="0">
+                <a:solidFill>
+                  <a:srgbClr val="444444"/>
+                </a:solidFill>
+                <a:latin typeface="Calibri"/>
+              </a:rPr>
+              <a:t>Four findings. Each one is an assumption an auditor has to check.</a:t>
             </a:r>
           </a:p>
         </p:txBody>
@@ -3776,8 +5157,8 @@
         </p:nvSpPr>
         <p:spPr>
           <a:xfrm>
-            <a:off x="457200" y="274320"/>
-            <a:ext cx="11247120" cy="822960"/>
+            <a:off x="548640" y="365760"/>
+            <a:ext cx="11064240" cy="1005840"/>
           </a:xfrm>
           <a:prstGeom prst="rect">
             <a:avLst/>
@@ -3790,7 +5171,11 @@
           </a:bodyPr>
           <a:lstStyle/>
           <a:p>
-            <a:pPr algn="l"/>
+            <a:pPr>
+              <a:spcAft>
+                <a:spcPts val="1000"/>
+              </a:spcAft>
+            </a:pPr>
             <a:r>
               <a:rPr sz="3000" b="1">
                 <a:solidFill>
@@ -3798,167 +5183,14 @@
                 </a:solidFill>
                 <a:latin typeface="Calibri"/>
               </a:rPr>
-              <a:t>Finding 3: the pairwise correction cancels a coalition of three</a:t>
-            </a:r>
-          </a:p>
-        </p:txBody>
-      </p:sp>
-      <p:sp>
-        <p:nvSpPr>
-          <p:cNvPr id="3" name="TextBox 2"/>
-          <p:cNvSpPr txBox="1"/>
-          <p:nvPr/>
-        </p:nvSpPr>
-        <p:spPr>
-          <a:xfrm>
-            <a:off x="457200" y="960120"/>
-            <a:ext cx="11247120" cy="548640"/>
-          </a:xfrm>
-          <a:prstGeom prst="rect">
-            <a:avLst/>
-          </a:prstGeom>
-          <a:noFill/>
-        </p:spPr>
-        <p:txBody>
-          <a:bodyPr wrap="square">
-            <a:spAutoFit/>
-          </a:bodyPr>
-          <a:lstStyle/>
-          <a:p>
-            <a:pPr algn="l"/>
-            <a:r>
-              <a:rPr sz="1600" b="0">
-                <a:solidFill>
-                  <a:srgbClr val="555555"/>
-                </a:solidFill>
-                <a:latin typeface="Calibri"/>
-              </a:rPr>
-              <a:t>Primary A, assistants B and C. The published method is scoped to two colluders.</a:t>
-            </a:r>
-          </a:p>
-        </p:txBody>
-      </p:sp>
-      <p:sp>
-        <p:nvSpPr>
-          <p:cNvPr id="4" name="TextBox 3"/>
-          <p:cNvSpPr txBox="1"/>
-          <p:nvPr/>
-        </p:nvSpPr>
-        <p:spPr>
-          <a:xfrm>
-            <a:off x="548640" y="1645920"/>
-            <a:ext cx="5669280" cy="1280160"/>
-          </a:xfrm>
-          <a:prstGeom prst="rect">
-            <a:avLst/>
-          </a:prstGeom>
-          <a:noFill/>
-        </p:spPr>
-        <p:txBody>
-          <a:bodyPr wrap="square">
-            <a:spAutoFit/>
-          </a:bodyPr>
-          <a:lstStyle/>
-          <a:p>
-            <a:pPr algn="l"/>
-            <a:r>
-              <a:rPr sz="2200" b="1">
-                <a:solidFill>
-                  <a:srgbClr val="1F3A5F"/>
-                </a:solidFill>
-                <a:latin typeface="Calibri"/>
-              </a:rPr>
-              <a:t>gamma(B; A) = gamma(C; A) = m in expectation, so</a:t>
-            </a:r>
-          </a:p>
-          <a:p>
-            <a:pPr algn="l"/>
-            <a:r>
-              <a:rPr sz="2200" b="1">
-                <a:solidFill>
-                  <a:srgbClr val="1F3A5F"/>
-                </a:solidFill>
-                <a:latin typeface="Calibri"/>
-              </a:rPr>
-              <a:t>Gamma(B; A) = m  -  max_k gamma(k; A) = m  -  m = 0</a:t>
-            </a:r>
-          </a:p>
-        </p:txBody>
-      </p:sp>
-      <p:sp>
-        <p:nvSpPr>
-          <p:cNvPr id="5" name="TextBox 4"/>
-          <p:cNvSpPr txBox="1"/>
-          <p:nvPr/>
-        </p:nvSpPr>
-        <p:spPr>
-          <a:xfrm>
-            <a:off x="548640" y="3017520"/>
-            <a:ext cx="5669280" cy="3474720"/>
-          </a:xfrm>
-          <a:prstGeom prst="rect">
-            <a:avLst/>
-          </a:prstGeom>
-          <a:noFill/>
-        </p:spPr>
-        <p:txBody>
-          <a:bodyPr wrap="square">
-            <a:spAutoFit/>
-          </a:bodyPr>
-          <a:lstStyle/>
-          <a:p>
-            <a:pPr algn="l"/>
-            <a:r>
-              <a:rPr sz="1500" b="0">
-                <a:solidFill>
-                  <a:srgbClr val="555555"/>
-                </a:solidFill>
-                <a:latin typeface="Calibri"/>
-              </a:rPr>
-              <a:t>•  The subtraction treats another coalition member as the competing explanation and removes the signal.</a:t>
-            </a:r>
-          </a:p>
-          <a:p>
-            <a:pPr algn="l"/>
-            <a:r>
-              <a:rPr sz="1500" b="0">
-                <a:solidFill>
-                  <a:srgbClr val="555555"/>
-                </a:solidFill>
-                <a:latin typeface="Calibri"/>
-              </a:rPr>
-              <a:t>•  Pair score is the minimum of both directions, so the true pair cannot exceed a positive threshold in the population limit.</a:t>
-            </a:r>
-          </a:p>
-          <a:p>
-            <a:pPr algn="l"/>
-            <a:r>
-              <a:rPr sz="1500" b="0">
-                <a:solidFill>
-                  <a:srgbClr val="555555"/>
-                </a:solidFill>
-                <a:latin typeface="Calibri"/>
-              </a:rPr>
-              <a:t>•  Empirically: AB score 0.006 nats at 500 rounds; the fixed rule returns no pair in 25%, 32%, 54%, 68% of games at 50, 100, 200, 500 rounds. More data, less detection.</a:t>
-            </a:r>
-          </a:p>
-          <a:p>
-            <a:pPr algn="l"/>
-            <a:r>
-              <a:rPr sz="1500" b="0">
-                <a:solidFill>
-                  <a:srgbClr val="555555"/>
-                </a:solidFill>
-                <a:latin typeface="Calibri"/>
-              </a:rPr>
-              <a:t>•  Ranking is unaffected (0.98 to 1.00). Coalition membership and direct dependence are different ground truths.</a:t>
+              <a:t>Finding 1: the wrong public state names an innocent pair</a:t>
             </a:r>
           </a:p>
         </p:txBody>
       </p:sp>
       <p:pic>
         <p:nvPicPr>
-          <p:cNvPr id="6" name="Picture 5" descr="fig_extensions.png"/>
+          <p:cNvPr id="3" name="Picture 2" descr="fig_scripted.png"/>
           <p:cNvPicPr>
             <a:picLocks noChangeAspect="1"/>
           </p:cNvPicPr>
@@ -3972,14 +5204,117 @@
         </p:blipFill>
         <p:spPr>
           <a:xfrm>
-            <a:off x="6400800" y="1828800"/>
-            <a:ext cx="5486400" cy="1628222"/>
+            <a:off x="548640" y="1554480"/>
+            <a:ext cx="6766560" cy="2368296"/>
           </a:xfrm>
           <a:prstGeom prst="rect">
             <a:avLst/>
           </a:prstGeom>
         </p:spPr>
       </p:pic>
+      <p:sp>
+        <p:nvSpPr>
+          <p:cNvPr id="4" name="TextBox 3"/>
+          <p:cNvSpPr txBox="1"/>
+          <p:nvPr/>
+        </p:nvSpPr>
+        <p:spPr>
+          <a:xfrm>
+            <a:off x="7680960" y="1645920"/>
+            <a:ext cx="3931919" cy="4754880"/>
+          </a:xfrm>
+          <a:prstGeom prst="rect">
+            <a:avLst/>
+          </a:prstGeom>
+          <a:noFill/>
+        </p:spPr>
+        <p:txBody>
+          <a:bodyPr wrap="square">
+            <a:spAutoFit/>
+          </a:bodyPr>
+          <a:lstStyle/>
+          <a:p>
+            <a:pPr>
+              <a:spcAft>
+                <a:spcPts val="1000"/>
+              </a:spcAft>
+            </a:pPr>
+            <a:r>
+              <a:rPr sz="1900" b="0">
+                <a:solidFill>
+                  <a:srgbClr val="444444"/>
+                </a:solidFill>
+                <a:latin typeface="Calibri"/>
+              </a:rPr>
+              <a:t>Two agents follow the same public rule: beat last round's majority.</a:t>
+            </a:r>
+          </a:p>
+          <a:p>
+            <a:pPr>
+              <a:spcAft>
+                <a:spcPts val="1000"/>
+              </a:spcAft>
+            </a:pPr>
+            <a:r>
+              <a:rPr sz="1900" b="0">
+                <a:solidFill>
+                  <a:srgbClr val="444444"/>
+                </a:solidFill>
+                <a:latin typeface="Calibri"/>
+              </a:rPr>
+              <a:t/>
+            </a:r>
+          </a:p>
+          <a:p>
+            <a:pPr>
+              <a:spcAft>
+                <a:spcPts val="1000"/>
+              </a:spcAft>
+            </a:pPr>
+            <a:r>
+              <a:rPr sz="1900" b="0">
+                <a:solidFill>
+                  <a:srgbClr val="444444"/>
+                </a:solidFill>
+                <a:latin typeface="Calibri"/>
+              </a:rPr>
+              <a:t>They agree every round without ever communicating.</a:t>
+            </a:r>
+          </a:p>
+          <a:p>
+            <a:pPr>
+              <a:spcAft>
+                <a:spcPts val="1000"/>
+              </a:spcAft>
+            </a:pPr>
+            <a:r>
+              <a:rPr sz="1900" b="0">
+                <a:solidFill>
+                  <a:srgbClr val="444444"/>
+                </a:solidFill>
+                <a:latin typeface="Calibri"/>
+              </a:rPr>
+              <a:t/>
+            </a:r>
+          </a:p>
+          <a:p>
+            <a:pPr>
+              <a:spcAft>
+                <a:spcPts val="1000"/>
+              </a:spcAft>
+            </a:pPr>
+            <a:r>
+              <a:rPr sz="1900" b="0">
+                <a:solidFill>
+                  <a:srgbClr val="444444"/>
+                </a:solidFill>
+                <a:latin typeface="Calibri"/>
+              </a:rPr>
+              <a:t>Every unconditioned statistic ranks them first in 96 to 100% of games.</a:t>
+            </a:r>
+          </a:p>
+        </p:txBody>
+      </p:sp>
     </p:spTree>
   </p:cSld>
   <p:clrMapOvr>
@@ -4006,8 +5341,8 @@
         </p:nvSpPr>
         <p:spPr>
           <a:xfrm>
-            <a:off x="457200" y="274320"/>
-            <a:ext cx="11247120" cy="822960"/>
+            <a:off x="548640" y="365760"/>
+            <a:ext cx="11064240" cy="1005840"/>
           </a:xfrm>
           <a:prstGeom prst="rect">
             <a:avLst/>
@@ -4020,7 +5355,11 @@
           </a:bodyPr>
           <a:lstStyle/>
           <a:p>
-            <a:pPr algn="l"/>
+            <a:pPr>
+              <a:spcAft>
+                <a:spcPts val="1000"/>
+              </a:spcAft>
+            </a:pPr>
             <a:r>
               <a:rPr sz="3000" b="1">
                 <a:solidFill>
@@ -4028,7 +5367,7 @@
                 </a:solidFill>
                 <a:latin typeface="Calibri"/>
               </a:rPr>
-              <a:t>Finding 4: ranking, detection and benefit come apart on real agents</a:t>
+              <a:t>Conditioning on the right state fixes it</a:t>
             </a:r>
           </a:p>
         </p:txBody>
@@ -4041,8 +5380,8 @@
         </p:nvSpPr>
         <p:spPr>
           <a:xfrm>
-            <a:off x="457200" y="960120"/>
-            <a:ext cx="11247120" cy="548640"/>
+            <a:off x="548640" y="1645920"/>
+            <a:ext cx="11064240" cy="4754880"/>
           </a:xfrm>
           <a:prstGeom prst="rect">
             <a:avLst/>
@@ -4055,311 +5394,83 @@
           </a:bodyPr>
           <a:lstStyle/>
           <a:p>
-            <a:pPr algn="l"/>
-            <a:r>
-              <a:rPr sz="1600" b="0">
-                <a:solidFill>
-                  <a:srgbClr val="555555"/>
-                </a:solidFill>
-                <a:latin typeface="Calibri"/>
-              </a:rPr>
-              <a:t>GPT-4.1-mini, 4 players, 25 rounds, two independent runs of 10 games x 3 conditions. Detector sees actions only.</a:t>
-            </a:r>
-          </a:p>
-        </p:txBody>
-      </p:sp>
-      <p:graphicFrame>
-        <p:nvGraphicFramePr>
-          <p:cNvPr id="4" name="Table 3"/>
-          <p:cNvGraphicFramePr>
-            <a:graphicFrameLocks noGrp="1"/>
-          </p:cNvGraphicFramePr>
-          <p:nvPr/>
-        </p:nvGraphicFramePr>
-        <p:xfrm>
-          <a:off x="548640" y="1737360"/>
-          <a:ext cx="11064240" cy="1645920"/>
-        </p:xfrm>
-        <a:graphic>
-          <a:graphicData uri="http://schemas.openxmlformats.org/drawingml/2006/table">
-            <a:tbl>
-              <a:tblPr firstRow="1" bandRow="1">
-                <a:tableStyleId>{5C22544A-7EE6-4342-B048-85BDC9FD1C3A}</a:tableStyleId>
-              </a:tblPr>
-              <a:tblGrid>
-                <a:gridCol w="2212848"/>
-                <a:gridCol w="2212848"/>
-                <a:gridCol w="2212848"/>
-                <a:gridCol w="2212848"/>
-                <a:gridCol w="2212848"/>
-              </a:tblGrid>
-              <a:tr h="548640">
-                <a:tc>
-                  <a:txBody>
-                    <a:bodyPr/>
-                    <a:lstStyle/>
-                    <a:p/>
-                  </a:txBody>
-                  <a:tcPr/>
-                </a:tc>
-                <a:tc>
-                  <a:txBody>
-                    <a:bodyPr/>
-                    <a:lstStyle/>
-                    <a:p>
-                      <a:r>
-                        <a:rPr sz="1400" b="1"/>
-                        <a:t>Pair ranked first (single games)</a:t>
-                      </a:r>
-                    </a:p>
-                  </a:txBody>
-                  <a:tcPr/>
-                </a:tc>
-                <a:tc>
-                  <a:txBody>
-                    <a:bodyPr/>
-                    <a:lstStyle/>
-                    <a:p>
-                      <a:r>
-                        <a:rPr sz="1400" b="1"/>
-                        <a:t>Fixed rule flags the pair</a:t>
-                      </a:r>
-                    </a:p>
-                  </a:txBody>
-                  <a:tcPr/>
-                </a:tc>
-                <a:tc>
-                  <a:txBody>
-                    <a:bodyPr/>
-                    <a:lstStyle/>
-                    <a:p>
-                      <a:r>
-                        <a:rPr sz="1400" b="1"/>
-                        <a:t>Holm rule on pooled control</a:t>
-                      </a:r>
-                    </a:p>
-                  </a:txBody>
-                  <a:tcPr/>
-                </a:tc>
-                <a:tc>
-                  <a:txBody>
-                    <a:bodyPr/>
-                    <a:lstStyle/>
-                    <a:p>
-                      <a:r>
-                        <a:rPr sz="1400" b="1"/>
-                        <a:t>Mean within-game score advantage</a:t>
-                      </a:r>
-                    </a:p>
-                  </a:txBody>
-                  <a:tcPr/>
-                </a:tc>
-              </a:tr>
-              <a:tr h="548640">
-                <a:tc>
-                  <a:txBody>
-                    <a:bodyPr/>
-                    <a:lstStyle/>
-                    <a:p>
-                      <a:r>
-                        <a:rPr sz="1400" b="0"/>
-                        <a:t>Run 1</a:t>
-                      </a:r>
-                    </a:p>
-                  </a:txBody>
-                  <a:tcPr/>
-                </a:tc>
-                <a:tc>
-                  <a:txBody>
-                    <a:bodyPr/>
-                    <a:lstStyle/>
-                    <a:p>
-                      <a:r>
-                        <a:rPr sz="1400" b="0"/>
-                        <a:t>9 / 10</a:t>
-                      </a:r>
-                    </a:p>
-                  </a:txBody>
-                  <a:tcPr/>
-                </a:tc>
-                <a:tc>
-                  <a:txBody>
-                    <a:bodyPr/>
-                    <a:lstStyle/>
-                    <a:p>
-                      <a:r>
-                        <a:rPr sz="1400" b="0"/>
-                        <a:t>5 / 10</a:t>
-                      </a:r>
-                    </a:p>
-                  </a:txBody>
-                  <a:tcPr/>
-                </a:tc>
-                <a:tc>
-                  <a:txBody>
-                    <a:bodyPr/>
-                    <a:lstStyle/>
-                    <a:p>
-                      <a:r>
-                        <a:rPr sz="1400" b="0"/>
-                        <a:t>flags Alpha-Delta (no planted coalition)</a:t>
-                      </a:r>
-                    </a:p>
-                  </a:txBody>
-                  <a:tcPr/>
-                </a:tc>
-                <a:tc>
-                  <a:txBody>
-                    <a:bodyPr/>
-                    <a:lstStyle/>
-                    <a:p>
-                      <a:r>
-                        <a:rPr sz="1400" b="0"/>
-                        <a:t>-0.25</a:t>
-                      </a:r>
-                    </a:p>
-                  </a:txBody>
-                  <a:tcPr/>
-                </a:tc>
-              </a:tr>
-              <a:tr h="548640">
-                <a:tc>
-                  <a:txBody>
-                    <a:bodyPr/>
-                    <a:lstStyle/>
-                    <a:p>
-                      <a:r>
-                        <a:rPr sz="1400" b="0"/>
-                        <a:t>Run 2</a:t>
-                      </a:r>
-                    </a:p>
-                  </a:txBody>
-                  <a:tcPr/>
-                </a:tc>
-                <a:tc>
-                  <a:txBody>
-                    <a:bodyPr/>
-                    <a:lstStyle/>
-                    <a:p>
-                      <a:r>
-                        <a:rPr sz="1400" b="0"/>
-                        <a:t>8 / 10</a:t>
-                      </a:r>
-                    </a:p>
-                  </a:txBody>
-                  <a:tcPr/>
-                </a:tc>
-                <a:tc>
-                  <a:txBody>
-                    <a:bodyPr/>
-                    <a:lstStyle/>
-                    <a:p>
-                      <a:r>
-                        <a:rPr sz="1400" b="0"/>
-                        <a:t>7 / 10</a:t>
-                      </a:r>
-                    </a:p>
-                  </a:txBody>
-                  <a:tcPr/>
-                </a:tc>
-                <a:tc>
-                  <a:txBody>
-                    <a:bodyPr/>
-                    <a:lstStyle/>
-                    <a:p>
-                      <a:r>
-                        <a:rPr sz="1400" b="0"/>
-                        <a:t>flags Charlie-Delta (no planted coalition)</a:t>
-                      </a:r>
-                    </a:p>
-                  </a:txBody>
-                  <a:tcPr/>
-                </a:tc>
-                <a:tc>
-                  <a:txBody>
-                    <a:bodyPr/>
-                    <a:lstStyle/>
-                    <a:p>
-                      <a:r>
-                        <a:rPr sz="1400" b="0"/>
-                        <a:t>+1.00</a:t>
-                      </a:r>
-                    </a:p>
-                  </a:txBody>
-                  <a:tcPr/>
-                </a:tc>
-              </a:tr>
-            </a:tbl>
-          </a:graphicData>
-        </a:graphic>
-      </p:graphicFrame>
-      <p:sp>
-        <p:nvSpPr>
-          <p:cNvPr id="5" name="TextBox 4"/>
-          <p:cNvSpPr txBox="1"/>
-          <p:nvPr/>
-        </p:nvSpPr>
-        <p:spPr>
-          <a:xfrm>
-            <a:off x="548640" y="3657600"/>
-            <a:ext cx="11064240" cy="2926080"/>
-          </a:xfrm>
-          <a:prstGeom prst="rect">
-            <a:avLst/>
-          </a:prstGeom>
-          <a:noFill/>
-        </p:spPr>
-        <p:txBody>
-          <a:bodyPr wrap="square">
-            <a:spAutoFit/>
-          </a:bodyPr>
-          <a:lstStyle/>
-          <a:p>
-            <a:pPr algn="l"/>
-            <a:r>
-              <a:rPr sz="1500" b="0">
-                <a:solidFill>
-                  <a:srgbClr val="555555"/>
-                </a:solidFill>
-                <a:latin typeface="Calibri"/>
-              </a:rPr>
-              <a:t>•  The private channel is visible in the actions: the team's dependence is 4 to 9 times any other pair's, and the messages show a sacrificial scheme ("I'll play rock to beat your scissors, so I can score while you lose").</a:t>
-            </a:r>
-          </a:p>
-          <a:p>
-            <a:pPr algn="l"/>
-            <a:r>
-              <a:rPr sz="1500" b="0">
-                <a:solidFill>
-                  <a:srgbClr val="555555"/>
-                </a:solidFill>
-                <a:latin typeface="Calibri"/>
-              </a:rPr>
-              <a:t>•  Single-game ranking was more successful than threshold detection, but both remain uncertain (ten games; ranking ties not audited).</a:t>
-            </a:r>
-          </a:p>
-          <a:p>
-            <a:pPr algn="l"/>
-            <a:r>
-              <a:rPr sz="1500" b="0">
-                <a:solidFill>
-                  <a:srgbClr val="555555"/>
-                </a:solidFill>
-                <a:latin typeface="Calibri"/>
-              </a:rPr>
-              <a:t>•  The fixed rule fires in 50 to 70% of single control games, matching the scripted all-random rate.</a:t>
-            </a:r>
-          </a:p>
-          <a:p>
-            <a:pPr algn="l"/>
-            <a:r>
-              <a:rPr sz="1500" b="0">
-                <a:solidFill>
-                  <a:srgbClr val="555555"/>
-                </a:solidFill>
-                <a:latin typeface="Calibri"/>
-              </a:rPr>
-              <a:t>•  Score advantage of -0.25 and +1.00 across runs does not establish a benefit from coordination.</a:t>
+            <a:pPr>
+              <a:spcAft>
+                <a:spcPts val="1000"/>
+              </a:spcAft>
+            </a:pPr>
+            <a:r>
+              <a:rPr sz="2200" b="0">
+                <a:solidFill>
+                  <a:srgbClr val="444444"/>
+                </a:solidFill>
+                <a:latin typeface="Calibri"/>
+              </a:rPr>
+              <a:t>Condition on the previous majority and the innocent pair's dependence is exactly zero.</a:t>
+            </a:r>
+          </a:p>
+          <a:p>
+            <a:pPr>
+              <a:spcAft>
+                <a:spcPts val="1000"/>
+              </a:spcAft>
+            </a:pPr>
+            <a:r>
+              <a:rPr sz="2200" b="0">
+                <a:solidFill>
+                  <a:srgbClr val="444444"/>
+                </a:solidFill>
+                <a:latin typeface="Calibri"/>
+              </a:rPr>
+              <a:t/>
+            </a:r>
+          </a:p>
+          <a:p>
+            <a:pPr>
+              <a:spcAft>
+                <a:spcPts val="1000"/>
+              </a:spcAft>
+            </a:pPr>
+            <a:r>
+              <a:rPr sz="2200" b="0">
+                <a:solidFill>
+                  <a:srgbClr val="444444"/>
+                </a:solidFill>
+                <a:latin typeface="Calibri"/>
+              </a:rPr>
+              <a:t>The true pair is ranked first in 98 to 100% of games.</a:t>
+            </a:r>
+          </a:p>
+          <a:p>
+            <a:pPr>
+              <a:spcAft>
+                <a:spcPts val="1000"/>
+              </a:spcAft>
+            </a:pPr>
+            <a:r>
+              <a:rPr sz="2200" b="0">
+                <a:solidFill>
+                  <a:srgbClr val="444444"/>
+                </a:solidFill>
+                <a:latin typeface="Calibri"/>
+              </a:rPr>
+              <a:t/>
+            </a:r>
+          </a:p>
+          <a:p>
+            <a:pPr>
+              <a:spcAft>
+                <a:spcPts val="1000"/>
+              </a:spcAft>
+            </a:pPr>
+            <a:r>
+              <a:rPr sz="2200" b="0">
+                <a:solidFill>
+                  <a:srgbClr val="444444"/>
+                </a:solidFill>
+                <a:latin typeface="Calibri"/>
+              </a:rPr>
+              <a:t>The innocent pair is never flagged.</a:t>
             </a:r>
           </a:p>
         </p:txBody>
@@ -4390,8 +5501,8 @@
         </p:nvSpPr>
         <p:spPr>
           <a:xfrm>
-            <a:off x="457200" y="274320"/>
-            <a:ext cx="11247120" cy="822960"/>
+            <a:off x="548640" y="365760"/>
+            <a:ext cx="11064240" cy="1005840"/>
           </a:xfrm>
           <a:prstGeom prst="rect">
             <a:avLst/>
@@ -4404,7 +5515,11 @@
           </a:bodyPr>
           <a:lstStyle/>
           <a:p>
-            <a:pPr algn="l"/>
+            <a:pPr>
+              <a:spcAft>
+                <a:spcPts val="1000"/>
+              </a:spcAft>
+            </a:pPr>
             <a:r>
               <a:rPr sz="3000" b="1">
                 <a:solidFill>
@@ -4412,49 +5527,14 @@
                 </a:solidFill>
                 <a:latin typeface="Calibri"/>
               </a:rPr>
-              <a:t>Exploratory: a Jacobian-lens readout of a coded proposal (gemma-4-12B-it)</a:t>
-            </a:r>
-          </a:p>
-        </p:txBody>
-      </p:sp>
-      <p:sp>
-        <p:nvSpPr>
-          <p:cNvPr id="3" name="TextBox 2"/>
-          <p:cNvSpPr txBox="1"/>
-          <p:nvPr/>
-        </p:nvSpPr>
-        <p:spPr>
-          <a:xfrm>
-            <a:off x="457200" y="960120"/>
-            <a:ext cx="11247120" cy="548640"/>
-          </a:xfrm>
-          <a:prstGeom prst="rect">
-            <a:avLst/>
-          </a:prstGeom>
-          <a:noFill/>
-        </p:spPr>
-        <p:txBody>
-          <a:bodyPr wrap="square">
-            <a:spAutoFit/>
-          </a:bodyPr>
-          <a:lstStyle/>
-          <a:p>
-            <a:pPr algn="l"/>
-            <a:r>
-              <a:rPr sz="1600" b="0">
-                <a:solidFill>
-                  <a:srgbClr val="555555"/>
-                </a:solidFill>
-                <a:latin typeface="Calibri"/>
-              </a:rPr>
-              <a:t>Does the workspace readout differ between adopting a partner's proposal and understanding it and refusing? The control Rose et al. (2026) describe.</a:t>
+              <a:t>Conditioning on the wrong state does not</a:t>
             </a:r>
           </a:p>
         </p:txBody>
       </p:sp>
       <p:pic>
         <p:nvPicPr>
-          <p:cNvPr id="4" name="Picture 3" descr="fig_lens_assay.png"/>
+          <p:cNvPr id="3" name="Picture 2" descr="fig_extensions.png"/>
           <p:cNvPicPr>
             <a:picLocks noChangeAspect="1"/>
           </p:cNvPicPr>
@@ -4468,8 +5548,8 @@
         </p:blipFill>
         <p:spPr>
           <a:xfrm>
-            <a:off x="457200" y="1737360"/>
-            <a:ext cx="6949440" cy="3281680"/>
+            <a:off x="548640" y="1554480"/>
+            <a:ext cx="6766560" cy="2008140"/>
           </a:xfrm>
           <a:prstGeom prst="rect">
             <a:avLst/>
@@ -4478,14 +5558,14 @@
       </p:pic>
       <p:sp>
         <p:nvSpPr>
-          <p:cNvPr id="5" name="TextBox 4"/>
+          <p:cNvPr id="4" name="TextBox 3"/>
           <p:cNvSpPr txBox="1"/>
           <p:nvPr/>
         </p:nvSpPr>
         <p:spPr>
           <a:xfrm>
-            <a:off x="7589520" y="1737360"/>
-            <a:ext cx="4297680" cy="4846320"/>
+            <a:off x="7680960" y="1645920"/>
+            <a:ext cx="3931919" cy="4754880"/>
           </a:xfrm>
           <a:prstGeom prst="rect">
             <a:avLst/>
@@ -4498,51 +5578,115 @@
           </a:bodyPr>
           <a:lstStyle/>
           <a:p>
-            <a:pPr algn="l"/>
-            <a:r>
-              <a:rPr sz="1400" b="0">
-                <a:solidFill>
-                  <a:srgbClr val="555555"/>
-                </a:solidFill>
-                <a:latin typeface="Calibri"/>
-              </a:rPr>
-              <a:t>•  30 base cases x 5 matched conditions, 150 receiver evaluations.</a:t>
-            </a:r>
-          </a:p>
-          <a:p>
-            <a:pPr algn="l"/>
-            <a:r>
-              <a:rPr sz="1400" b="0">
-                <a:solidFill>
-                  <a:srgbClr val="555555"/>
-                </a:solidFill>
-                <a:latin typeface="Calibri"/>
-              </a:rPr>
-              <a:t>•  Unauthorised adoption never occurred: 30/30 abstentions. The intended contrast is unresolved.</a:t>
-            </a:r>
-          </a:p>
-          <a:p>
-            <a:pPr algn="l"/>
-            <a:r>
-              <a:rPr sz="1400" b="0">
-                <a:solidFill>
-                  <a:srgbClr val="555555"/>
-                </a:solidFill>
-                <a:latin typeface="Calibri"/>
-              </a:rPr>
-              <a:t>•  Readout strongly recovered the nominated item during permitted adoption (rank 0) but not during abstention (at chance).</a:t>
-            </a:r>
-          </a:p>
-          <a:p>
-            <a:pPr algn="l"/>
-            <a:r>
-              <a:rPr sz="1400" b="0">
-                <a:solidFill>
-                  <a:srgbClr val="555555"/>
-                </a:solidFill>
-                <a:latin typeface="Calibri"/>
-              </a:rPr>
-              <a:t>•  This does not establish that the proposal is absent from the model, nor that the workspace shows actions rather than understanding; one lens, one position, best-rank aggregation with censoring.</a:t>
+            <a:pPr>
+              <a:spcAft>
+                <a:spcPts val="1000"/>
+              </a:spcAft>
+            </a:pPr>
+            <a:r>
+              <a:rPr sz="1900" b="0">
+                <a:solidFill>
+                  <a:srgbClr val="444444"/>
+                </a:solidFill>
+                <a:latin typeface="Calibri"/>
+              </a:rPr>
+              <a:t>Give the innocent pair a rule keyed on a richer state (the previous full profile).</a:t>
+            </a:r>
+          </a:p>
+          <a:p>
+            <a:pPr>
+              <a:spcAft>
+                <a:spcPts val="1000"/>
+              </a:spcAft>
+            </a:pPr>
+            <a:r>
+              <a:rPr sz="1900" b="0">
+                <a:solidFill>
+                  <a:srgbClr val="444444"/>
+                </a:solidFill>
+                <a:latin typeface="Calibri"/>
+              </a:rPr>
+              <a:t/>
+            </a:r>
+          </a:p>
+          <a:p>
+            <a:pPr>
+              <a:spcAft>
+                <a:spcPts val="1000"/>
+              </a:spcAft>
+            </a:pPr>
+            <a:r>
+              <a:rPr sz="1900" b="0">
+                <a:solidFill>
+                  <a:srgbClr val="444444"/>
+                </a:solidFill>
+                <a:latin typeface="Calibri"/>
+              </a:rPr>
+              <a:t>Majority conditioning fails in 100% of games.</a:t>
+            </a:r>
+          </a:p>
+          <a:p>
+            <a:pPr>
+              <a:spcAft>
+                <a:spcPts val="1000"/>
+              </a:spcAft>
+            </a:pPr>
+            <a:r>
+              <a:rPr sz="1900" b="0">
+                <a:solidFill>
+                  <a:srgbClr val="444444"/>
+                </a:solidFill>
+                <a:latin typeface="Calibri"/>
+              </a:rPr>
+              <a:t/>
+            </a:r>
+          </a:p>
+          <a:p>
+            <a:pPr>
+              <a:spcAft>
+                <a:spcPts val="1000"/>
+              </a:spcAft>
+            </a:pPr>
+            <a:r>
+              <a:rPr sz="1900" b="0">
+                <a:solidFill>
+                  <a:srgbClr val="444444"/>
+                </a:solidFill>
+                <a:latin typeface="Calibri"/>
+              </a:rPr>
+              <a:t>Conditioning on the full profile works, but only once the game is long compared with the number of states.</a:t>
+            </a:r>
+          </a:p>
+          <a:p>
+            <a:pPr>
+              <a:spcAft>
+                <a:spcPts val="1000"/>
+              </a:spcAft>
+            </a:pPr>
+            <a:r>
+              <a:rPr sz="1900" b="0">
+                <a:solidFill>
+                  <a:srgbClr val="444444"/>
+                </a:solidFill>
+                <a:latin typeface="Calibri"/>
+              </a:rPr>
+              <a:t/>
+            </a:r>
+          </a:p>
+          <a:p>
+            <a:pPr>
+              <a:spcAft>
+                <a:spcPts val="1000"/>
+              </a:spcAft>
+            </a:pPr>
+            <a:r>
+              <a:rPr sz="1900" b="0">
+                <a:solidFill>
+                  <a:srgbClr val="444444"/>
+                </a:solidFill>
+                <a:latin typeface="Calibri"/>
+              </a:rPr>
+              <a:t>An auditor has to know what the agents could innocently be reacting to.</a:t>
             </a:r>
           </a:p>
         </p:txBody>
@@ -4573,8 +5717,8 @@
         </p:nvSpPr>
         <p:spPr>
           <a:xfrm>
-            <a:off x="457200" y="274320"/>
-            <a:ext cx="11247120" cy="822960"/>
+            <a:off x="548640" y="365760"/>
+            <a:ext cx="11064240" cy="1005840"/>
           </a:xfrm>
           <a:prstGeom prst="rect">
             <a:avLst/>
@@ -4587,7 +5731,11 @@
           </a:bodyPr>
           <a:lstStyle/>
           <a:p>
-            <a:pPr algn="l"/>
+            <a:pPr>
+              <a:spcAft>
+                <a:spcPts val="1000"/>
+              </a:spcAft>
+            </a:pPr>
             <a:r>
               <a:rPr sz="3000" b="1">
                 <a:solidFill>
@@ -4595,7 +5743,7 @@
                 </a:solidFill>
                 <a:latin typeface="Calibri"/>
               </a:rPr>
-              <a:t>What an auditor must check before treating dependence as evidence</a:t>
+              <a:t>Finding 2: removing bias is not calibration</a:t>
             </a:r>
           </a:p>
         </p:txBody>
@@ -4608,8 +5756,8 @@
         </p:nvSpPr>
         <p:spPr>
           <a:xfrm>
-            <a:off x="548640" y="1463040"/>
-            <a:ext cx="11064240" cy="5029200"/>
+            <a:off x="548640" y="1645920"/>
+            <a:ext cx="11064240" cy="4754880"/>
           </a:xfrm>
           <a:prstGeom prst="rect">
             <a:avLst/>
@@ -4622,77 +5770,115 @@
           </a:bodyPr>
           <a:lstStyle/>
           <a:p>
-            <a:pPr algn="l"/>
-            <a:r>
-              <a:rPr sz="1700" b="0">
-                <a:solidFill>
-                  <a:srgbClr val="555555"/>
-                </a:solidFill>
-                <a:latin typeface="Calibri"/>
-              </a:rPr>
-              <a:t>•  Is the conditioning state at least as rich as any public rule the agents could innocently follow? If not, a confident verdict can be wrong in every game.</a:t>
-            </a:r>
-          </a:p>
-          <a:p>
-            <a:pPr algn="l"/>
-            <a:r>
-              <a:rPr sz="1700" b="0">
-                <a:solidFill>
-                  <a:srgbClr val="555555"/>
-                </a:solidFill>
-                <a:latin typeface="Calibri"/>
-              </a:rPr>
-              <a:t>•  Is the decision rule calibrated on the right null? Bias correction is not calibration; a rule calibrated on one family of nulls flagged pairs in LLM controls without a planted coalition.</a:t>
-            </a:r>
-          </a:p>
-          <a:p>
-            <a:pPr algn="l"/>
-            <a:r>
-              <a:rPr sz="1700" b="0">
-                <a:solidFill>
-                  <a:srgbClr val="555555"/>
-                </a:solidFill>
-                <a:latin typeface="Calibri"/>
-              </a:rPr>
-              <a:t>•  Could the coalition have more than two members? Pairwise net scores cancel a three-member coalition, and detection falls as evidence accumulates.</a:t>
-            </a:r>
-          </a:p>
-          <a:p>
-            <a:pPr algn="l"/>
-            <a:r>
-              <a:rPr sz="1700" b="0">
-                <a:solidFill>
-                  <a:srgbClr val="555555"/>
-                </a:solidFill>
-                <a:latin typeface="Calibri"/>
-              </a:rPr>
-              <a:t>•  Which outcome is being claimed: ranking, thresholded detection, or demonstrated benefit? They are different numbers.</a:t>
-            </a:r>
-          </a:p>
-          <a:p>
-            <a:pPr algn="l"/>
-            <a:r>
-              <a:rPr sz="1700" b="0">
-                <a:solidFill>
-                  <a:srgbClr val="555555"/>
-                </a:solidFill>
-                <a:latin typeface="Calibri"/>
-              </a:rPr>
-              <a:t>•  Everything is reproducible from the repository: 7,400 scripted games in about 16 minutes on two CPU cores, LLM pilot under 2 USD, lens assay on one Colab GPU.</a:t>
-            </a:r>
-          </a:p>
-        </p:txBody>
-      </p:sp>
-      <p:sp>
-        <p:nvSpPr>
-          <p:cNvPr id="4" name="TextBox 3"/>
+            <a:pPr>
+              <a:spcAft>
+                <a:spcPts val="1000"/>
+              </a:spcAft>
+            </a:pPr>
+            <a:r>
+              <a:rPr sz="2200" b="0">
+                <a:solidFill>
+                  <a:srgbClr val="444444"/>
+                </a:solidFill>
+                <a:latin typeface="Calibri"/>
+              </a:rPr>
+              <a:t>Plug-in mutual information is biased upward by about 0.08 nats at 25 rounds. The published threshold is 0.05.</a:t>
+            </a:r>
+          </a:p>
+          <a:p>
+            <a:pPr>
+              <a:spcAft>
+                <a:spcPts val="1000"/>
+              </a:spcAft>
+            </a:pPr>
+            <a:r>
+              <a:rPr sz="2200" b="0">
+                <a:solidFill>
+                  <a:srgbClr val="444444"/>
+                </a:solidFill>
+                <a:latin typeface="Calibri"/>
+              </a:rPr>
+              <a:t/>
+            </a:r>
+          </a:p>
+          <a:p>
+            <a:pPr>
+              <a:spcAft>
+                <a:spcPts val="1000"/>
+              </a:spcAft>
+            </a:pPr>
+            <a:r>
+              <a:rPr sz="2200" b="0">
+                <a:solidFill>
+                  <a:srgbClr val="444444"/>
+                </a:solidFill>
+                <a:latin typeface="Calibri"/>
+              </a:rPr>
+              <a:t>Subtracting the bias helps, but the fixed threshold still fires in about half of all-random 25-round games.</a:t>
+            </a:r>
+          </a:p>
+          <a:p>
+            <a:pPr>
+              <a:spcAft>
+                <a:spcPts val="1000"/>
+              </a:spcAft>
+            </a:pPr>
+            <a:r>
+              <a:rPr sz="2200" b="0">
+                <a:solidFill>
+                  <a:srgbClr val="444444"/>
+                </a:solidFill>
+                <a:latin typeface="Calibri"/>
+              </a:rPr>
+              <a:t/>
+            </a:r>
+          </a:p>
+          <a:p>
+            <a:pPr>
+              <a:spcAft>
+                <a:spcPts val="1000"/>
+              </a:spcAft>
+            </a:pPr>
+            <a:r>
+              <a:rPr sz="2200" b="0">
+                <a:solidFill>
+                  <a:srgbClr val="444444"/>
+                </a:solidFill>
+                <a:latin typeface="Calibri"/>
+              </a:rPr>
+              <a:t>A Holm-corrected permutation rule holds the scripted false-positive rate at 3 to 6%, at a cost in power.</a:t>
+            </a:r>
+          </a:p>
+        </p:txBody>
+      </p:sp>
+    </p:spTree>
+  </p:cSld>
+  <p:clrMapOvr>
+    <a:masterClrMapping/>
+  </p:clrMapOvr>
+</p:sld>
+</file>
+
+<file path=ppt/slides/slide9.xml><?xml version="1.0" encoding="utf-8"?>
+<p:sld xmlns:a="http://schemas.openxmlformats.org/drawingml/2006/main" xmlns:p="http://schemas.openxmlformats.org/presentationml/2006/main" xmlns:r="http://schemas.openxmlformats.org/officeDocument/2006/relationships">
+  <p:cSld>
+    <p:spTree>
+      <p:nvGrpSpPr>
+        <p:cNvPr id="1" name=""/>
+        <p:cNvGrpSpPr/>
+        <p:nvPr/>
+      </p:nvGrpSpPr>
+      <p:grpSpPr/>
+      <p:sp>
+        <p:nvSpPr>
+          <p:cNvPr id="2" name="TextBox 1"/>
           <p:cNvSpPr txBox="1"/>
           <p:nvPr/>
         </p:nvSpPr>
         <p:spPr>
           <a:xfrm>
-            <a:off x="548640" y="6126480"/>
-            <a:ext cx="11064240" cy="548640"/>
+            <a:off x="548640" y="365760"/>
+            <a:ext cx="11064240" cy="1005840"/>
           </a:xfrm>
           <a:prstGeom prst="rect">
             <a:avLst/>
@@ -4705,15 +5891,122 @@
           </a:bodyPr>
           <a:lstStyle/>
           <a:p>
-            <a:pPr algn="l"/>
-            <a:r>
-              <a:rPr sz="1400" b="0">
-                <a:solidFill>
-                  <a:srgbClr val="D9822B"/>
-                </a:solidFill>
-                <a:latin typeface="Calibri"/>
-              </a:rPr>
-              <a:t>github.com/in-a-quantum-world/collusion-net-influence</a:t>
+            <a:pPr>
+              <a:spcAft>
+                <a:spcPts val="1000"/>
+              </a:spcAft>
+            </a:pPr>
+            <a:r>
+              <a:rPr sz="3000" b="1">
+                <a:solidFill>
+                  <a:srgbClr val="1F3A5F"/>
+                </a:solidFill>
+                <a:latin typeface="Calibri"/>
+              </a:rPr>
+              <a:t>The calibration does not transfer</a:t>
+            </a:r>
+          </a:p>
+        </p:txBody>
+      </p:sp>
+      <p:sp>
+        <p:nvSpPr>
+          <p:cNvPr id="3" name="TextBox 2"/>
+          <p:cNvSpPr txBox="1"/>
+          <p:nvPr/>
+        </p:nvSpPr>
+        <p:spPr>
+          <a:xfrm>
+            <a:off x="548640" y="1645920"/>
+            <a:ext cx="11064240" cy="4754880"/>
+          </a:xfrm>
+          <a:prstGeom prst="rect">
+            <a:avLst/>
+          </a:prstGeom>
+          <a:noFill/>
+        </p:spPr>
+        <p:txBody>
+          <a:bodyPr wrap="square">
+            <a:spAutoFit/>
+          </a:bodyPr>
+          <a:lstStyle/>
+          <a:p>
+            <a:pPr>
+              <a:spcAft>
+                <a:spcPts val="1000"/>
+              </a:spcAft>
+            </a:pPr>
+            <a:r>
+              <a:rPr sz="2200" b="0">
+                <a:solidFill>
+                  <a:srgbClr val="444444"/>
+                </a:solidFill>
+                <a:latin typeface="Calibri"/>
+              </a:rPr>
+              <a:t>On the pooled GPT-4.1-mini control, with no planted coalition, the Holm rule flags a pair at Holm p = 0.012.</a:t>
+            </a:r>
+          </a:p>
+          <a:p>
+            <a:pPr>
+              <a:spcAft>
+                <a:spcPts val="1000"/>
+              </a:spcAft>
+            </a:pPr>
+            <a:r>
+              <a:rPr sz="2200" b="0">
+                <a:solidFill>
+                  <a:srgbClr val="444444"/>
+                </a:solidFill>
+                <a:latin typeface="Calibri"/>
+              </a:rPr>
+              <a:t/>
+            </a:r>
+          </a:p>
+          <a:p>
+            <a:pPr>
+              <a:spcAft>
+                <a:spcPts val="1000"/>
+              </a:spcAft>
+            </a:pPr>
+            <a:r>
+              <a:rPr sz="2200" b="0">
+                <a:solidFill>
+                  <a:srgbClr val="444444"/>
+                </a:solidFill>
+                <a:latin typeface="Calibri"/>
+              </a:rPr>
+              <a:t>It did so in both runs.</a:t>
+            </a:r>
+          </a:p>
+          <a:p>
+            <a:pPr>
+              <a:spcAft>
+                <a:spcPts val="1000"/>
+              </a:spcAft>
+            </a:pPr>
+            <a:r>
+              <a:rPr sz="2200" b="0">
+                <a:solidFill>
+                  <a:srgbClr val="444444"/>
+                </a:solidFill>
+                <a:latin typeface="Calibri"/>
+              </a:rPr>
+              <a:t/>
+            </a:r>
+          </a:p>
+          <a:p>
+            <a:pPr>
+              <a:spcAft>
+                <a:spcPts val="1000"/>
+              </a:spcAft>
+            </a:pPr>
+            <a:r>
+              <a:rPr sz="2200" b="0">
+                <a:solidFill>
+                  <a:srgbClr val="444444"/>
+                </a:solidFill>
+                <a:latin typeface="Calibri"/>
+              </a:rPr>
+              <a:t>A small p-value says the dependence is larger than the chosen shuffle produces. It does not say the agents colluded.</a:t>
             </a:r>
           </a:p>
         </p:txBody>

</xml_diff>